<commit_message>
feat: add plan and updates slides to deck
</commit_message>
<xml_diff>
--- a/presentation/typediff_update.pptx
+++ b/presentation/typediff_update.pptx
@@ -10,6 +10,8 @@
     <p:sldId id="258" r:id="rId10"/>
     <p:sldId id="259" r:id="rId11"/>
     <p:sldId id="260" r:id="rId12"/>
+    <p:sldId id="261" r:id="rId13"/>
+    <p:sldId id="262" r:id="rId14"/>
   </p:sldIdLst>
   <p:sldSz cx="12191695" cy="6858000" type="screen4x3"/>
   <p:notesSz cx="6858000" cy="9144000"/>
@@ -786,7 +788,147 @@
           <a:lstStyle/>
           <a:p>
             <a:r>
-              <a:t>We expect three things. First, new confirmed bugs in ty and possibly mypy, each with a minimal repro and a spec reference, checked against the trackers so we do not file duplicates. Second, a documented dataset of disagreements, labelled as real bug, intended, known or noise, with evidence. Third, a reusable pipeline that cheaply discards known differences so humans only look at real candidates, with measured funnel numbers. We are not promising a specific number of bugs. So far the pipeline is built, the first corpus has been run, and triage is in progress.</a:t>
+              <a:t>This is our plan as six stages. Setup is done: tools are pinned, the docs corpus is in and the knowledge base passes its self-test. We are now in stage two, running the hand-written and harvested seeds and triaging the findings into patterns. Next the LLM mutates promising hits, then generates new programs for under-covered areas and hunts crashes, and every result is judged deterministically. Then we judge and file: spec rule, CPython as oracle, duplicate search and a minimal repro, one issue per root cause. The last stage is the write-up. Three principles run through it: free LLMs generate but never judge, we judge patterns rather than single findings, and we search trackers before filing. The LLM budget is about 20 dollars in total.</a:t>
+            </a:r>
+          </a:p>
+        </p:txBody>
+      </p:sp>
+      <p:sp>
+        <p:nvSpPr>
+          <p:cNvPr id="4" name="Slide Number Placeholder 3"/>
+          <p:cNvSpPr>
+            <a:spLocks noGrp="1"/>
+          </p:cNvSpPr>
+          <p:nvPr>
+            <p:ph type="sldNum" idx="5" sz="quarter"/>
+          </p:nvPr>
+        </p:nvSpPr>
+        <p:spPr/>
+      </p:sp>
+    </p:spTree>
+  </p:cSld>
+  <p:clrMapOvr>
+    <a:masterClrMapping/>
+  </p:clrMapOvr>
+</p:notes>
+</file>
+
+<file path=ppt/notesSlides/notesSlide6.xml><?xml version="1.0" encoding="utf-8"?>
+<p:notes xmlns:a="http://schemas.openxmlformats.org/drawingml/2006/main" xmlns:p="http://schemas.openxmlformats.org/presentationml/2006/main" xmlns:r="http://schemas.openxmlformats.org/officeDocument/2006/relationships">
+  <p:cSld>
+    <p:spTree>
+      <p:nvGrpSpPr>
+        <p:cNvPr id="1" name=""/>
+        <p:cNvGrpSpPr/>
+        <p:nvPr/>
+      </p:nvGrpSpPr>
+      <p:grpSpPr>
+        <a:xfrm>
+          <a:off x="0" y="0"/>
+          <a:ext cx="0" cy="0"/>
+          <a:chOff x="0" y="0"/>
+          <a:chExt cx="0" cy="0"/>
+        </a:xfrm>
+      </p:grpSpPr>
+      <p:sp>
+        <p:nvSpPr>
+          <p:cNvPr id="2" name="Slide Image Placeholder 1"/>
+          <p:cNvSpPr>
+            <a:spLocks noGrp="1"/>
+          </p:cNvSpPr>
+          <p:nvPr>
+            <p:ph type="sldImg" idx="2"/>
+          </p:nvPr>
+        </p:nvSpPr>
+        <p:spPr/>
+      </p:sp>
+      <p:sp>
+        <p:nvSpPr>
+          <p:cNvPr id="3" name="Notes Placeholder 2"/>
+          <p:cNvSpPr>
+            <a:spLocks noGrp="1"/>
+          </p:cNvSpPr>
+          <p:nvPr>
+            <p:ph type="body" idx="3" sz="quarter"/>
+          </p:nvPr>
+        </p:nvSpPr>
+        <p:spPr/>
+        <p:txBody>
+          <a:bodyPr/>
+          <a:lstStyle/>
+          <a:p>
+            <a:r>
+              <a:t>Here is what is done so far. The pipeline works end to end: it runs mypy, ty, pyright and CPython, compares them, filters known differences with a knowledge base and groups the rest into patterns. Our first probe, a hand-written Self seed, became ty issue 4656. The maintainers closed it as intended behaviour, and a related display bug is ty 4673, so we learned to argue the other tool's side before filing. The corpus is 27 hand-written seeds plus 4,849 harvested programs. The first full run gave 7,480 findings in 618 patterns, with no LLM involved. We triaged the top five patterns and all were harness noise or design differences, so no confirmed bug yet. That exposed a misleading evidence flag, and we fixed it along with several other pipeline issues, and 81 tests pass. A re-run on the fixed pipeline is in progress, so we have no results from it to show today.</a:t>
+            </a:r>
+          </a:p>
+        </p:txBody>
+      </p:sp>
+      <p:sp>
+        <p:nvSpPr>
+          <p:cNvPr id="4" name="Slide Number Placeholder 3"/>
+          <p:cNvSpPr>
+            <a:spLocks noGrp="1"/>
+          </p:cNvSpPr>
+          <p:nvPr>
+            <p:ph type="sldNum" idx="5" sz="quarter"/>
+          </p:nvPr>
+        </p:nvSpPr>
+        <p:spPr/>
+      </p:sp>
+    </p:spTree>
+  </p:cSld>
+  <p:clrMapOvr>
+    <a:masterClrMapping/>
+  </p:clrMapOvr>
+</p:notes>
+</file>
+
+<file path=ppt/notesSlides/notesSlide7.xml><?xml version="1.0" encoding="utf-8"?>
+<p:notes xmlns:a="http://schemas.openxmlformats.org/drawingml/2006/main" xmlns:p="http://schemas.openxmlformats.org/presentationml/2006/main" xmlns:r="http://schemas.openxmlformats.org/officeDocument/2006/relationships">
+  <p:cSld>
+    <p:spTree>
+      <p:nvGrpSpPr>
+        <p:cNvPr id="1" name=""/>
+        <p:cNvGrpSpPr/>
+        <p:nvPr/>
+      </p:nvGrpSpPr>
+      <p:grpSpPr>
+        <a:xfrm>
+          <a:off x="0" y="0"/>
+          <a:ext cx="0" cy="0"/>
+          <a:chOff x="0" y="0"/>
+          <a:chExt cx="0" cy="0"/>
+        </a:xfrm>
+      </p:grpSpPr>
+      <p:sp>
+        <p:nvSpPr>
+          <p:cNvPr id="2" name="Slide Image Placeholder 1"/>
+          <p:cNvSpPr>
+            <a:spLocks noGrp="1"/>
+          </p:cNvSpPr>
+          <p:nvPr>
+            <p:ph type="sldImg" idx="2"/>
+          </p:nvPr>
+        </p:nvSpPr>
+        <p:spPr/>
+      </p:sp>
+      <p:sp>
+        <p:nvSpPr>
+          <p:cNvPr id="3" name="Notes Placeholder 2"/>
+          <p:cNvSpPr>
+            <a:spLocks noGrp="1"/>
+          </p:cNvSpPr>
+          <p:nvPr>
+            <p:ph type="body" idx="3" sz="quarter"/>
+          </p:nvPr>
+        </p:nvSpPr>
+        <p:spPr/>
+        <p:txBody>
+          <a:bodyPr/>
+          <a:lstStyle/>
+          <a:p>
+            <a:r>
+              <a:t>We expect three things. First, new confirmed bugs in ty and possibly mypy, each with a minimal repro and a spec reference, checked against the trackers so we do not file duplicates. Second, a documented dataset of disagreements, labelled as real bug, intended, known or noise, with evidence. Third, a reusable pipeline that cheaply discards known differences so humans only look at real candidates, with measured funnel numbers. We are not promising a specific number of bugs. The status of all this is on the updates slide.</a:t>
             </a:r>
           </a:p>
         </p:txBody>
@@ -5729,7 +5871,7 @@
                 </a:solidFill>
                 <a:latin typeface="Calibri"/>
               </a:rPr>
-              <a:t>Architecture: from programs to filed bugs</a:t>
+              <a:t>Pipeline: from programs to filed bugs</a:t>
             </a:r>
           </a:p>
         </p:txBody>
@@ -7530,7 +7672,7 @@
                 </a:solidFill>
                 <a:latin typeface="Calibri"/>
               </a:rPr>
-              <a:t>Expected outcomes</a:t>
+              <a:t>Plan: six stages</a:t>
             </a:r>
           </a:p>
         </p:txBody>
@@ -7695,17 +7837,146 @@
       </p:sp>
       <p:sp>
         <p:nvSpPr>
-          <p:cNvPr id="7" name="Oval 6"/>
+          <p:cNvPr id="7" name="Pentagon 6"/>
           <p:cNvSpPr/>
           <p:nvPr/>
         </p:nvSpPr>
         <p:spPr>
           <a:xfrm>
-            <a:off x="685800" y="1600200"/>
-            <a:ext cx="640080" cy="640080"/>
-          </a:xfrm>
-          <a:prstGeom prst="ellipse">
-            <a:avLst/>
+            <a:off x="411480" y="1463040"/>
+            <a:ext cx="1803349" cy="914400"/>
+          </a:xfrm>
+          <a:prstGeom prst="homePlate">
+            <a:avLst>
+              <a:gd name="adj" fmla="val 18000"/>
+            </a:avLst>
+          </a:prstGeom>
+          <a:solidFill>
+            <a:srgbClr val="1F6FB5"/>
+          </a:solidFill>
+          <a:ln w="25400">
+            <a:solidFill>
+              <a:srgbClr val="1F6FB5"/>
+            </a:solidFill>
+          </a:ln>
+          <a:effectLst/>
+        </p:spPr>
+        <p:style>
+          <a:lnRef idx="1">
+            <a:schemeClr val="accent1"/>
+          </a:lnRef>
+          <a:fillRef idx="3">
+            <a:schemeClr val="accent1"/>
+          </a:fillRef>
+          <a:effectRef idx="2">
+            <a:schemeClr val="accent1"/>
+          </a:effectRef>
+          <a:fontRef idx="minor">
+            <a:schemeClr val="lt1"/>
+          </a:fontRef>
+        </p:style>
+        <p:txBody>
+          <a:bodyPr rtlCol="0" anchor="ctr" wrap="square" lIns="18288" rIns="18288" tIns="18288" bIns="18288"/>
+          <a:lstStyle/>
+          <a:p>
+            <a:pPr algn="ctr"/>
+            <a:r>
+              <a:rPr sz="2400" b="1">
+                <a:solidFill>
+                  <a:srgbClr val="FFFFFF"/>
+                </a:solidFill>
+                <a:latin typeface="Calibri"/>
+              </a:rPr>
+              <a:t>1</a:t>
+            </a:r>
+          </a:p>
+        </p:txBody>
+      </p:sp>
+      <p:sp>
+        <p:nvSpPr>
+          <p:cNvPr id="8" name="TextBox 7"/>
+          <p:cNvSpPr txBox="1"/>
+          <p:nvPr/>
+        </p:nvSpPr>
+        <p:spPr>
+          <a:xfrm>
+            <a:off x="411480" y="2514600"/>
+            <a:ext cx="1803349" cy="777240"/>
+          </a:xfrm>
+          <a:prstGeom prst="rect">
+            <a:avLst/>
+          </a:prstGeom>
+          <a:noFill/>
+        </p:spPr>
+        <p:txBody>
+          <a:bodyPr wrap="square" anchor="t" lIns="45720" rIns="45720">
+            <a:spAutoFit/>
+          </a:bodyPr>
+          <a:lstStyle/>
+          <a:p>
+            <a:pPr algn="l"/>
+            <a:r>
+              <a:rPr sz="1600" b="1">
+                <a:solidFill>
+                  <a:srgbClr val="1B263B"/>
+                </a:solidFill>
+                <a:latin typeface="Calibri"/>
+              </a:rPr>
+              <a:t>Setup</a:t>
+            </a:r>
+          </a:p>
+        </p:txBody>
+      </p:sp>
+      <p:sp>
+        <p:nvSpPr>
+          <p:cNvPr id="9" name="TextBox 8"/>
+          <p:cNvSpPr txBox="1"/>
+          <p:nvPr/>
+        </p:nvSpPr>
+        <p:spPr>
+          <a:xfrm>
+            <a:off x="411480" y="3291840"/>
+            <a:ext cx="1803349" cy="1737360"/>
+          </a:xfrm>
+          <a:prstGeom prst="rect">
+            <a:avLst/>
+          </a:prstGeom>
+          <a:noFill/>
+        </p:spPr>
+        <p:txBody>
+          <a:bodyPr wrap="square" anchor="t" lIns="45720" rIns="45720">
+            <a:spAutoFit/>
+          </a:bodyPr>
+          <a:lstStyle/>
+          <a:p>
+            <a:pPr algn="l"/>
+            <a:r>
+              <a:rPr sz="1400" b="0">
+                <a:solidFill>
+                  <a:srgbClr val="1B263B"/>
+                </a:solidFill>
+                <a:latin typeface="Calibri"/>
+              </a:rPr>
+              <a:t>Pinned tools: ty 0.0.84, mypy 2.4.0, pyright. Docs corpus, knowledge-base self-test.</a:t>
+            </a:r>
+          </a:p>
+        </p:txBody>
+      </p:sp>
+      <p:sp>
+        <p:nvSpPr>
+          <p:cNvPr id="10" name="Rounded Rectangle 9"/>
+          <p:cNvSpPr/>
+          <p:nvPr/>
+        </p:nvSpPr>
+        <p:spPr>
+          <a:xfrm>
+            <a:off x="457200" y="5029200"/>
+            <a:ext cx="1529029" cy="384048"/>
+          </a:xfrm>
+          <a:prstGeom prst="roundRect">
+            <a:avLst>
+              <a:gd name="adj" fmla="val 50000"/>
+            </a:avLst>
           </a:prstGeom>
           <a:solidFill>
             <a:srgbClr val="1F6FB5"/>
@@ -7730,32 +8001,89 @@
           </a:fontRef>
         </p:style>
         <p:txBody>
-          <a:bodyPr rtlCol="0" anchor="ctr" wrap="square" lIns="0" rIns="0" tIns="0" bIns="0"/>
+          <a:bodyPr rtlCol="0" anchor="ctr" wrap="square" lIns="18288" rIns="18288" tIns="18288" bIns="18288"/>
           <a:lstStyle/>
           <a:p>
             <a:pPr algn="ctr"/>
             <a:r>
-              <a:rPr sz="2600" b="1">
+              <a:rPr sz="1400" b="1">
                 <a:solidFill>
                   <a:srgbClr val="FFFFFF"/>
                 </a:solidFill>
                 <a:latin typeface="Calibri"/>
               </a:rPr>
-              <a:t>1</a:t>
-            </a:r>
-          </a:p>
-        </p:txBody>
-      </p:sp>
-      <p:sp>
-        <p:nvSpPr>
-          <p:cNvPr id="8" name="TextBox 7"/>
+              <a:t>Done</a:t>
+            </a:r>
+          </a:p>
+        </p:txBody>
+      </p:sp>
+      <p:sp>
+        <p:nvSpPr>
+          <p:cNvPr id="11" name="Chevron 10"/>
+          <p:cNvSpPr/>
+          <p:nvPr/>
+        </p:nvSpPr>
+        <p:spPr>
+          <a:xfrm>
+            <a:off x="2324557" y="1463040"/>
+            <a:ext cx="1803349" cy="914400"/>
+          </a:xfrm>
+          <a:prstGeom prst="chevron">
+            <a:avLst>
+              <a:gd name="adj" fmla="val 18000"/>
+            </a:avLst>
+          </a:prstGeom>
+          <a:solidFill>
+            <a:srgbClr val="FFFFFF"/>
+          </a:solidFill>
+          <a:ln w="25400">
+            <a:solidFill>
+              <a:srgbClr val="1F6FB5"/>
+            </a:solidFill>
+          </a:ln>
+          <a:effectLst/>
+        </p:spPr>
+        <p:style>
+          <a:lnRef idx="1">
+            <a:schemeClr val="accent1"/>
+          </a:lnRef>
+          <a:fillRef idx="3">
+            <a:schemeClr val="accent1"/>
+          </a:fillRef>
+          <a:effectRef idx="2">
+            <a:schemeClr val="accent1"/>
+          </a:effectRef>
+          <a:fontRef idx="minor">
+            <a:schemeClr val="lt1"/>
+          </a:fontRef>
+        </p:style>
+        <p:txBody>
+          <a:bodyPr rtlCol="0" anchor="ctr" wrap="square" lIns="18288" rIns="18288" tIns="18288" bIns="18288"/>
+          <a:lstStyle/>
+          <a:p>
+            <a:pPr algn="ctr"/>
+            <a:r>
+              <a:rPr sz="2400" b="1">
+                <a:solidFill>
+                  <a:srgbClr val="1B263B"/>
+                </a:solidFill>
+                <a:latin typeface="Calibri"/>
+              </a:rPr>
+              <a:t>2</a:t>
+            </a:r>
+          </a:p>
+        </p:txBody>
+      </p:sp>
+      <p:sp>
+        <p:nvSpPr>
+          <p:cNvPr id="12" name="TextBox 11"/>
           <p:cNvSpPr txBox="1"/>
           <p:nvPr/>
         </p:nvSpPr>
         <p:spPr>
           <a:xfrm>
-            <a:off x="1645920" y="1463040"/>
-            <a:ext cx="3017520" cy="914400"/>
+            <a:off x="2324557" y="2514600"/>
+            <a:ext cx="1803349" cy="777240"/>
           </a:xfrm>
           <a:prstGeom prst="rect">
             <a:avLst/>
@@ -7763,34 +8091,34 @@
           <a:noFill/>
         </p:spPr>
         <p:txBody>
-          <a:bodyPr wrap="square" anchor="ctr" lIns="45720" rIns="45720">
+          <a:bodyPr wrap="square" anchor="t" lIns="45720" rIns="45720">
             <a:spAutoFit/>
           </a:bodyPr>
           <a:lstStyle/>
           <a:p>
             <a:pPr algn="l"/>
             <a:r>
-              <a:rPr sz="2400" b="1">
+              <a:rPr sz="1600" b="1">
                 <a:solidFill>
                   <a:srgbClr val="1B263B"/>
                 </a:solidFill>
                 <a:latin typeface="Calibri"/>
               </a:rPr>
-              <a:t>New, confirmed bugs</a:t>
-            </a:r>
-          </a:p>
-        </p:txBody>
-      </p:sp>
-      <p:sp>
-        <p:nvSpPr>
-          <p:cNvPr id="9" name="TextBox 8"/>
+              <a:t>Seed run and triage</a:t>
+            </a:r>
+          </a:p>
+        </p:txBody>
+      </p:sp>
+      <p:sp>
+        <p:nvSpPr>
+          <p:cNvPr id="13" name="TextBox 12"/>
           <p:cNvSpPr txBox="1"/>
           <p:nvPr/>
         </p:nvSpPr>
         <p:spPr>
           <a:xfrm>
-            <a:off x="4754880" y="1463040"/>
-            <a:ext cx="6796735" cy="914400"/>
+            <a:off x="2324557" y="3291840"/>
+            <a:ext cx="1803349" cy="1737360"/>
           </a:xfrm>
           <a:prstGeom prst="rect">
             <a:avLst/>
@@ -7798,36 +8126,857 @@
           <a:noFill/>
         </p:spPr>
         <p:txBody>
-          <a:bodyPr wrap="square" anchor="ctr" lIns="45720" rIns="45720">
+          <a:bodyPr wrap="square" anchor="t" lIns="45720" rIns="45720">
             <a:spAutoFit/>
           </a:bodyPr>
           <a:lstStyle/>
           <a:p>
             <a:pPr algn="l"/>
             <a:r>
-              <a:rPr sz="1800" b="0">
+              <a:rPr sz="1400" b="0">
                 <a:solidFill>
                   <a:srgbClr val="1B263B"/>
                 </a:solidFill>
                 <a:latin typeface="Calibri"/>
               </a:rPr>
-              <a:t>Reportable bugs in ty (and mypy): minimal repros filed upstream with spec references, checked against the trackers for duplicates.</a:t>
-            </a:r>
-          </a:p>
-        </p:txBody>
-      </p:sp>
-      <p:sp>
-        <p:nvSpPr>
-          <p:cNvPr id="10" name="Oval 9"/>
+              <a:t>Hand-written seeds + 4,849 harvested programs. Group findings into patterns, teach the KB what is noise.</a:t>
+            </a:r>
+          </a:p>
+        </p:txBody>
+      </p:sp>
+      <p:sp>
+        <p:nvSpPr>
+          <p:cNvPr id="14" name="Rounded Rectangle 13"/>
           <p:cNvSpPr/>
           <p:nvPr/>
         </p:nvSpPr>
         <p:spPr>
           <a:xfrm>
-            <a:off x="685800" y="2788920"/>
-            <a:ext cx="640080" cy="640080"/>
-          </a:xfrm>
-          <a:prstGeom prst="ellipse">
+            <a:off x="2370277" y="5029200"/>
+            <a:ext cx="1529029" cy="384048"/>
+          </a:xfrm>
+          <a:prstGeom prst="roundRect">
+            <a:avLst>
+              <a:gd name="adj" fmla="val 50000"/>
+            </a:avLst>
+          </a:prstGeom>
+          <a:solidFill>
+            <a:srgbClr val="FFFFFF"/>
+          </a:solidFill>
+          <a:ln w="25400">
+            <a:solidFill>
+              <a:srgbClr val="1F6FB5"/>
+            </a:solidFill>
+          </a:ln>
+          <a:effectLst/>
+        </p:spPr>
+        <p:style>
+          <a:lnRef idx="1">
+            <a:schemeClr val="accent1"/>
+          </a:lnRef>
+          <a:fillRef idx="3">
+            <a:schemeClr val="accent1"/>
+          </a:fillRef>
+          <a:effectRef idx="2">
+            <a:schemeClr val="accent1"/>
+          </a:effectRef>
+          <a:fontRef idx="minor">
+            <a:schemeClr val="lt1"/>
+          </a:fontRef>
+        </p:style>
+        <p:txBody>
+          <a:bodyPr rtlCol="0" anchor="ctr" wrap="square" lIns="18288" rIns="18288" tIns="18288" bIns="18288"/>
+          <a:lstStyle/>
+          <a:p>
+            <a:pPr algn="ctr"/>
+            <a:r>
+              <a:rPr sz="1400" b="1">
+                <a:solidFill>
+                  <a:srgbClr val="1F6FB5"/>
+                </a:solidFill>
+                <a:latin typeface="Calibri"/>
+              </a:rPr>
+              <a:t>In progress</a:t>
+            </a:r>
+          </a:p>
+        </p:txBody>
+      </p:sp>
+      <p:sp>
+        <p:nvSpPr>
+          <p:cNvPr id="15" name="Chevron 14"/>
+          <p:cNvSpPr/>
+          <p:nvPr/>
+        </p:nvSpPr>
+        <p:spPr>
+          <a:xfrm>
+            <a:off x="4237634" y="1463040"/>
+            <a:ext cx="1803349" cy="914400"/>
+          </a:xfrm>
+          <a:prstGeom prst="chevron">
+            <a:avLst>
+              <a:gd name="adj" fmla="val 18000"/>
+            </a:avLst>
+          </a:prstGeom>
+          <a:solidFill>
+            <a:srgbClr val="E9ECF1"/>
+          </a:solidFill>
+          <a:ln>
+            <a:noFill/>
+          </a:ln>
+          <a:effectLst/>
+        </p:spPr>
+        <p:style>
+          <a:lnRef idx="1">
+            <a:schemeClr val="accent1"/>
+          </a:lnRef>
+          <a:fillRef idx="3">
+            <a:schemeClr val="accent1"/>
+          </a:fillRef>
+          <a:effectRef idx="2">
+            <a:schemeClr val="accent1"/>
+          </a:effectRef>
+          <a:fontRef idx="minor">
+            <a:schemeClr val="lt1"/>
+          </a:fontRef>
+        </p:style>
+        <p:txBody>
+          <a:bodyPr rtlCol="0" anchor="ctr" wrap="square" lIns="18288" rIns="18288" tIns="18288" bIns="18288"/>
+          <a:lstStyle/>
+          <a:p>
+            <a:pPr algn="ctr"/>
+            <a:r>
+              <a:rPr sz="2400" b="1">
+                <a:solidFill>
+                  <a:srgbClr val="1B263B"/>
+                </a:solidFill>
+                <a:latin typeface="Calibri"/>
+              </a:rPr>
+              <a:t>3</a:t>
+            </a:r>
+          </a:p>
+        </p:txBody>
+      </p:sp>
+      <p:sp>
+        <p:nvSpPr>
+          <p:cNvPr id="16" name="TextBox 15"/>
+          <p:cNvSpPr txBox="1"/>
+          <p:nvPr/>
+        </p:nvSpPr>
+        <p:spPr>
+          <a:xfrm>
+            <a:off x="4237634" y="2514600"/>
+            <a:ext cx="1803349" cy="777240"/>
+          </a:xfrm>
+          <a:prstGeom prst="rect">
+            <a:avLst/>
+          </a:prstGeom>
+          <a:noFill/>
+        </p:spPr>
+        <p:txBody>
+          <a:bodyPr wrap="square" anchor="t" lIns="45720" rIns="45720">
+            <a:spAutoFit/>
+          </a:bodyPr>
+          <a:lstStyle/>
+          <a:p>
+            <a:pPr algn="l"/>
+            <a:r>
+              <a:rPr sz="1600" b="1">
+                <a:solidFill>
+                  <a:srgbClr val="1B263B"/>
+                </a:solidFill>
+                <a:latin typeface="Calibri"/>
+              </a:rPr>
+              <a:t>LLM mutation</a:t>
+            </a:r>
+          </a:p>
+        </p:txBody>
+      </p:sp>
+      <p:sp>
+        <p:nvSpPr>
+          <p:cNvPr id="17" name="TextBox 16"/>
+          <p:cNvSpPr txBox="1"/>
+          <p:nvPr/>
+        </p:nvSpPr>
+        <p:spPr>
+          <a:xfrm>
+            <a:off x="4237634" y="3291840"/>
+            <a:ext cx="1803349" cy="1737360"/>
+          </a:xfrm>
+          <a:prstGeom prst="rect">
+            <a:avLst/>
+          </a:prstGeom>
+          <a:noFill/>
+        </p:spPr>
+        <p:txBody>
+          <a:bodyPr wrap="square" anchor="t" lIns="45720" rIns="45720">
+            <a:spAutoFit/>
+          </a:bodyPr>
+          <a:lstStyle/>
+          <a:p>
+            <a:pPr algn="l"/>
+            <a:r>
+              <a:rPr sz="1400" b="0">
+                <a:solidFill>
+                  <a:srgbClr val="1B263B"/>
+                </a:solidFill>
+                <a:latin typeface="Calibri"/>
+              </a:rPr>
+              <a:t>Variants of promising hits (feature crossovers), judged deterministically.</a:t>
+            </a:r>
+          </a:p>
+        </p:txBody>
+      </p:sp>
+      <p:sp>
+        <p:nvSpPr>
+          <p:cNvPr id="18" name="Rounded Rectangle 17"/>
+          <p:cNvSpPr/>
+          <p:nvPr/>
+        </p:nvSpPr>
+        <p:spPr>
+          <a:xfrm>
+            <a:off x="4283354" y="5029200"/>
+            <a:ext cx="1529029" cy="384048"/>
+          </a:xfrm>
+          <a:prstGeom prst="roundRect">
+            <a:avLst>
+              <a:gd name="adj" fmla="val 50000"/>
+            </a:avLst>
+          </a:prstGeom>
+          <a:solidFill>
+            <a:srgbClr val="E9ECF1"/>
+          </a:solidFill>
+          <a:ln>
+            <a:noFill/>
+          </a:ln>
+          <a:effectLst/>
+        </p:spPr>
+        <p:style>
+          <a:lnRef idx="1">
+            <a:schemeClr val="accent1"/>
+          </a:lnRef>
+          <a:fillRef idx="3">
+            <a:schemeClr val="accent1"/>
+          </a:fillRef>
+          <a:effectRef idx="2">
+            <a:schemeClr val="accent1"/>
+          </a:effectRef>
+          <a:fontRef idx="minor">
+            <a:schemeClr val="lt1"/>
+          </a:fontRef>
+        </p:style>
+        <p:txBody>
+          <a:bodyPr rtlCol="0" anchor="ctr" wrap="square" lIns="18288" rIns="18288" tIns="18288" bIns="18288"/>
+          <a:lstStyle/>
+          <a:p>
+            <a:pPr algn="ctr"/>
+            <a:r>
+              <a:rPr sz="1400" b="1">
+                <a:solidFill>
+                  <a:srgbClr val="6B7280"/>
+                </a:solidFill>
+                <a:latin typeface="Calibri"/>
+              </a:rPr>
+              <a:t>Upcoming</a:t>
+            </a:r>
+          </a:p>
+        </p:txBody>
+      </p:sp>
+      <p:sp>
+        <p:nvSpPr>
+          <p:cNvPr id="19" name="Chevron 18"/>
+          <p:cNvSpPr/>
+          <p:nvPr/>
+        </p:nvSpPr>
+        <p:spPr>
+          <a:xfrm>
+            <a:off x="6150711" y="1463040"/>
+            <a:ext cx="1803349" cy="914400"/>
+          </a:xfrm>
+          <a:prstGeom prst="chevron">
+            <a:avLst>
+              <a:gd name="adj" fmla="val 18000"/>
+            </a:avLst>
+          </a:prstGeom>
+          <a:solidFill>
+            <a:srgbClr val="E9ECF1"/>
+          </a:solidFill>
+          <a:ln>
+            <a:noFill/>
+          </a:ln>
+          <a:effectLst/>
+        </p:spPr>
+        <p:style>
+          <a:lnRef idx="1">
+            <a:schemeClr val="accent1"/>
+          </a:lnRef>
+          <a:fillRef idx="3">
+            <a:schemeClr val="accent1"/>
+          </a:fillRef>
+          <a:effectRef idx="2">
+            <a:schemeClr val="accent1"/>
+          </a:effectRef>
+          <a:fontRef idx="minor">
+            <a:schemeClr val="lt1"/>
+          </a:fontRef>
+        </p:style>
+        <p:txBody>
+          <a:bodyPr rtlCol="0" anchor="ctr" wrap="square" lIns="18288" rIns="18288" tIns="18288" bIns="18288"/>
+          <a:lstStyle/>
+          <a:p>
+            <a:pPr algn="ctr"/>
+            <a:r>
+              <a:rPr sz="2400" b="1">
+                <a:solidFill>
+                  <a:srgbClr val="1B263B"/>
+                </a:solidFill>
+                <a:latin typeface="Calibri"/>
+              </a:rPr>
+              <a:t>4</a:t>
+            </a:r>
+          </a:p>
+        </p:txBody>
+      </p:sp>
+      <p:sp>
+        <p:nvSpPr>
+          <p:cNvPr id="20" name="TextBox 19"/>
+          <p:cNvSpPr txBox="1"/>
+          <p:nvPr/>
+        </p:nvSpPr>
+        <p:spPr>
+          <a:xfrm>
+            <a:off x="6150711" y="2514600"/>
+            <a:ext cx="1803349" cy="777240"/>
+          </a:xfrm>
+          <a:prstGeom prst="rect">
+            <a:avLst/>
+          </a:prstGeom>
+          <a:noFill/>
+        </p:spPr>
+        <p:txBody>
+          <a:bodyPr wrap="square" anchor="t" lIns="45720" rIns="45720">
+            <a:spAutoFit/>
+          </a:bodyPr>
+          <a:lstStyle/>
+          <a:p>
+            <a:pPr algn="l"/>
+            <a:r>
+              <a:rPr sz="1600" b="1">
+                <a:solidFill>
+                  <a:srgbClr val="1B263B"/>
+                </a:solidFill>
+                <a:latin typeface="Calibri"/>
+              </a:rPr>
+              <a:t>LLM generation + crash hunting</a:t>
+            </a:r>
+          </a:p>
+        </p:txBody>
+      </p:sp>
+      <p:sp>
+        <p:nvSpPr>
+          <p:cNvPr id="21" name="TextBox 20"/>
+          <p:cNvSpPr txBox="1"/>
+          <p:nvPr/>
+        </p:nvSpPr>
+        <p:spPr>
+          <a:xfrm>
+            <a:off x="6150711" y="3291840"/>
+            <a:ext cx="1803349" cy="1737360"/>
+          </a:xfrm>
+          <a:prstGeom prst="rect">
+            <a:avLst/>
+          </a:prstGeom>
+          <a:noFill/>
+        </p:spPr>
+        <p:txBody>
+          <a:bodyPr wrap="square" anchor="t" lIns="45720" rIns="45720">
+            <a:spAutoFit/>
+          </a:bodyPr>
+          <a:lstStyle/>
+          <a:p>
+            <a:pPr algn="l"/>
+            <a:r>
+              <a:rPr sz="1400" b="0">
+                <a:solidFill>
+                  <a:srgbClr val="1B263B"/>
+                </a:solidFill>
+                <a:latin typeface="Calibri"/>
+              </a:rPr>
+              <a:t>New programs in under-covered areas: ParamSpec, TypedDict, overloads, recursive aliases.</a:t>
+            </a:r>
+          </a:p>
+        </p:txBody>
+      </p:sp>
+      <p:sp>
+        <p:nvSpPr>
+          <p:cNvPr id="22" name="Rounded Rectangle 21"/>
+          <p:cNvSpPr/>
+          <p:nvPr/>
+        </p:nvSpPr>
+        <p:spPr>
+          <a:xfrm>
+            <a:off x="6196431" y="5029200"/>
+            <a:ext cx="1529029" cy="384048"/>
+          </a:xfrm>
+          <a:prstGeom prst="roundRect">
+            <a:avLst>
+              <a:gd name="adj" fmla="val 50000"/>
+            </a:avLst>
+          </a:prstGeom>
+          <a:solidFill>
+            <a:srgbClr val="E9ECF1"/>
+          </a:solidFill>
+          <a:ln>
+            <a:noFill/>
+          </a:ln>
+          <a:effectLst/>
+        </p:spPr>
+        <p:style>
+          <a:lnRef idx="1">
+            <a:schemeClr val="accent1"/>
+          </a:lnRef>
+          <a:fillRef idx="3">
+            <a:schemeClr val="accent1"/>
+          </a:fillRef>
+          <a:effectRef idx="2">
+            <a:schemeClr val="accent1"/>
+          </a:effectRef>
+          <a:fontRef idx="minor">
+            <a:schemeClr val="lt1"/>
+          </a:fontRef>
+        </p:style>
+        <p:txBody>
+          <a:bodyPr rtlCol="0" anchor="ctr" wrap="square" lIns="18288" rIns="18288" tIns="18288" bIns="18288"/>
+          <a:lstStyle/>
+          <a:p>
+            <a:pPr algn="ctr"/>
+            <a:r>
+              <a:rPr sz="1400" b="1">
+                <a:solidFill>
+                  <a:srgbClr val="6B7280"/>
+                </a:solidFill>
+                <a:latin typeface="Calibri"/>
+              </a:rPr>
+              <a:t>Upcoming</a:t>
+            </a:r>
+          </a:p>
+        </p:txBody>
+      </p:sp>
+      <p:sp>
+        <p:nvSpPr>
+          <p:cNvPr id="23" name="Chevron 22"/>
+          <p:cNvSpPr/>
+          <p:nvPr/>
+        </p:nvSpPr>
+        <p:spPr>
+          <a:xfrm>
+            <a:off x="8063788" y="1463040"/>
+            <a:ext cx="1803349" cy="914400"/>
+          </a:xfrm>
+          <a:prstGeom prst="chevron">
+            <a:avLst>
+              <a:gd name="adj" fmla="val 18000"/>
+            </a:avLst>
+          </a:prstGeom>
+          <a:solidFill>
+            <a:srgbClr val="E9ECF1"/>
+          </a:solidFill>
+          <a:ln>
+            <a:noFill/>
+          </a:ln>
+          <a:effectLst/>
+        </p:spPr>
+        <p:style>
+          <a:lnRef idx="1">
+            <a:schemeClr val="accent1"/>
+          </a:lnRef>
+          <a:fillRef idx="3">
+            <a:schemeClr val="accent1"/>
+          </a:fillRef>
+          <a:effectRef idx="2">
+            <a:schemeClr val="accent1"/>
+          </a:effectRef>
+          <a:fontRef idx="minor">
+            <a:schemeClr val="lt1"/>
+          </a:fontRef>
+        </p:style>
+        <p:txBody>
+          <a:bodyPr rtlCol="0" anchor="ctr" wrap="square" lIns="18288" rIns="18288" tIns="18288" bIns="18288"/>
+          <a:lstStyle/>
+          <a:p>
+            <a:pPr algn="ctr"/>
+            <a:r>
+              <a:rPr sz="2400" b="1">
+                <a:solidFill>
+                  <a:srgbClr val="1B263B"/>
+                </a:solidFill>
+                <a:latin typeface="Calibri"/>
+              </a:rPr>
+              <a:t>5</a:t>
+            </a:r>
+          </a:p>
+        </p:txBody>
+      </p:sp>
+      <p:sp>
+        <p:nvSpPr>
+          <p:cNvPr id="24" name="TextBox 23"/>
+          <p:cNvSpPr txBox="1"/>
+          <p:nvPr/>
+        </p:nvSpPr>
+        <p:spPr>
+          <a:xfrm>
+            <a:off x="8063788" y="2514600"/>
+            <a:ext cx="1803349" cy="777240"/>
+          </a:xfrm>
+          <a:prstGeom prst="rect">
+            <a:avLst/>
+          </a:prstGeom>
+          <a:noFill/>
+        </p:spPr>
+        <p:txBody>
+          <a:bodyPr wrap="square" anchor="t" lIns="45720" rIns="45720">
+            <a:spAutoFit/>
+          </a:bodyPr>
+          <a:lstStyle/>
+          <a:p>
+            <a:pPr algn="l"/>
+            <a:r>
+              <a:rPr sz="1600" b="1">
+                <a:solidFill>
+                  <a:srgbClr val="1B263B"/>
+                </a:solidFill>
+                <a:latin typeface="Calibri"/>
+              </a:rPr>
+              <a:t>Judging and filing</a:t>
+            </a:r>
+          </a:p>
+        </p:txBody>
+      </p:sp>
+      <p:sp>
+        <p:nvSpPr>
+          <p:cNvPr id="25" name="TextBox 24"/>
+          <p:cNvSpPr txBox="1"/>
+          <p:nvPr/>
+        </p:nvSpPr>
+        <p:spPr>
+          <a:xfrm>
+            <a:off x="8063788" y="3291840"/>
+            <a:ext cx="1803349" cy="1737360"/>
+          </a:xfrm>
+          <a:prstGeom prst="rect">
+            <a:avLst/>
+          </a:prstGeom>
+          <a:noFill/>
+        </p:spPr>
+        <p:txBody>
+          <a:bodyPr wrap="square" anchor="t" lIns="45720" rIns="45720">
+            <a:spAutoFit/>
+          </a:bodyPr>
+          <a:lstStyle/>
+          <a:p>
+            <a:pPr algn="l"/>
+            <a:r>
+              <a:rPr sz="1400" b="0">
+                <a:solidFill>
+                  <a:srgbClr val="1B263B"/>
+                </a:solidFill>
+                <a:latin typeface="Calibri"/>
+              </a:rPr>
+              <a:t>Spec rule, CPython oracle, duplicate search, minimal repro. One issue per root cause.</a:t>
+            </a:r>
+          </a:p>
+        </p:txBody>
+      </p:sp>
+      <p:sp>
+        <p:nvSpPr>
+          <p:cNvPr id="26" name="Rounded Rectangle 25"/>
+          <p:cNvSpPr/>
+          <p:nvPr/>
+        </p:nvSpPr>
+        <p:spPr>
+          <a:xfrm>
+            <a:off x="8109508" y="5029200"/>
+            <a:ext cx="1529029" cy="384048"/>
+          </a:xfrm>
+          <a:prstGeom prst="roundRect">
+            <a:avLst>
+              <a:gd name="adj" fmla="val 50000"/>
+            </a:avLst>
+          </a:prstGeom>
+          <a:solidFill>
+            <a:srgbClr val="E9ECF1"/>
+          </a:solidFill>
+          <a:ln>
+            <a:noFill/>
+          </a:ln>
+          <a:effectLst/>
+        </p:spPr>
+        <p:style>
+          <a:lnRef idx="1">
+            <a:schemeClr val="accent1"/>
+          </a:lnRef>
+          <a:fillRef idx="3">
+            <a:schemeClr val="accent1"/>
+          </a:fillRef>
+          <a:effectRef idx="2">
+            <a:schemeClr val="accent1"/>
+          </a:effectRef>
+          <a:fontRef idx="minor">
+            <a:schemeClr val="lt1"/>
+          </a:fontRef>
+        </p:style>
+        <p:txBody>
+          <a:bodyPr rtlCol="0" anchor="ctr" wrap="square" lIns="18288" rIns="18288" tIns="18288" bIns="18288"/>
+          <a:lstStyle/>
+          <a:p>
+            <a:pPr algn="ctr"/>
+            <a:r>
+              <a:rPr sz="1400" b="1">
+                <a:solidFill>
+                  <a:srgbClr val="6B7280"/>
+                </a:solidFill>
+                <a:latin typeface="Calibri"/>
+              </a:rPr>
+              <a:t>Upcoming</a:t>
+            </a:r>
+          </a:p>
+        </p:txBody>
+      </p:sp>
+      <p:sp>
+        <p:nvSpPr>
+          <p:cNvPr id="27" name="Chevron 26"/>
+          <p:cNvSpPr/>
+          <p:nvPr/>
+        </p:nvSpPr>
+        <p:spPr>
+          <a:xfrm>
+            <a:off x="9976866" y="1463040"/>
+            <a:ext cx="1803349" cy="914400"/>
+          </a:xfrm>
+          <a:prstGeom prst="chevron">
+            <a:avLst>
+              <a:gd name="adj" fmla="val 18000"/>
+            </a:avLst>
+          </a:prstGeom>
+          <a:solidFill>
+            <a:srgbClr val="E9ECF1"/>
+          </a:solidFill>
+          <a:ln>
+            <a:noFill/>
+          </a:ln>
+          <a:effectLst/>
+        </p:spPr>
+        <p:style>
+          <a:lnRef idx="1">
+            <a:schemeClr val="accent1"/>
+          </a:lnRef>
+          <a:fillRef idx="3">
+            <a:schemeClr val="accent1"/>
+          </a:fillRef>
+          <a:effectRef idx="2">
+            <a:schemeClr val="accent1"/>
+          </a:effectRef>
+          <a:fontRef idx="minor">
+            <a:schemeClr val="lt1"/>
+          </a:fontRef>
+        </p:style>
+        <p:txBody>
+          <a:bodyPr rtlCol="0" anchor="ctr" wrap="square" lIns="18288" rIns="18288" tIns="18288" bIns="18288"/>
+          <a:lstStyle/>
+          <a:p>
+            <a:pPr algn="ctr"/>
+            <a:r>
+              <a:rPr sz="2400" b="1">
+                <a:solidFill>
+                  <a:srgbClr val="1B263B"/>
+                </a:solidFill>
+                <a:latin typeface="Calibri"/>
+              </a:rPr>
+              <a:t>6</a:t>
+            </a:r>
+          </a:p>
+        </p:txBody>
+      </p:sp>
+      <p:sp>
+        <p:nvSpPr>
+          <p:cNvPr id="28" name="TextBox 27"/>
+          <p:cNvSpPr txBox="1"/>
+          <p:nvPr/>
+        </p:nvSpPr>
+        <p:spPr>
+          <a:xfrm>
+            <a:off x="9976866" y="2514600"/>
+            <a:ext cx="1803349" cy="777240"/>
+          </a:xfrm>
+          <a:prstGeom prst="rect">
+            <a:avLst/>
+          </a:prstGeom>
+          <a:noFill/>
+        </p:spPr>
+        <p:txBody>
+          <a:bodyPr wrap="square" anchor="t" lIns="45720" rIns="45720">
+            <a:spAutoFit/>
+          </a:bodyPr>
+          <a:lstStyle/>
+          <a:p>
+            <a:pPr algn="l"/>
+            <a:r>
+              <a:rPr sz="1600" b="1">
+                <a:solidFill>
+                  <a:srgbClr val="1B263B"/>
+                </a:solidFill>
+                <a:latin typeface="Calibri"/>
+              </a:rPr>
+              <a:t>Write-up</a:t>
+            </a:r>
+          </a:p>
+        </p:txBody>
+      </p:sp>
+      <p:sp>
+        <p:nvSpPr>
+          <p:cNvPr id="29" name="TextBox 28"/>
+          <p:cNvSpPr txBox="1"/>
+          <p:nvPr/>
+        </p:nvSpPr>
+        <p:spPr>
+          <a:xfrm>
+            <a:off x="9976866" y="3291840"/>
+            <a:ext cx="1803349" cy="1737360"/>
+          </a:xfrm>
+          <a:prstGeom prst="rect">
+            <a:avLst/>
+          </a:prstGeom>
+          <a:noFill/>
+        </p:spPr>
+        <p:txBody>
+          <a:bodyPr wrap="square" anchor="t" lIns="45720" rIns="45720">
+            <a:spAutoFit/>
+          </a:bodyPr>
+          <a:lstStyle/>
+          <a:p>
+            <a:pPr algn="l"/>
+            <a:r>
+              <a:rPr sz="1400" b="0">
+                <a:solidFill>
+                  <a:srgbClr val="1B263B"/>
+                </a:solidFill>
+                <a:latin typeface="Calibri"/>
+              </a:rPr>
+              <a:t>Results tables, discrepancy dataset, filed issues.</a:t>
+            </a:r>
+          </a:p>
+        </p:txBody>
+      </p:sp>
+      <p:sp>
+        <p:nvSpPr>
+          <p:cNvPr id="30" name="Rounded Rectangle 29"/>
+          <p:cNvSpPr/>
+          <p:nvPr/>
+        </p:nvSpPr>
+        <p:spPr>
+          <a:xfrm>
+            <a:off x="10022586" y="5029200"/>
+            <a:ext cx="1529029" cy="384048"/>
+          </a:xfrm>
+          <a:prstGeom prst="roundRect">
+            <a:avLst>
+              <a:gd name="adj" fmla="val 50000"/>
+            </a:avLst>
+          </a:prstGeom>
+          <a:solidFill>
+            <a:srgbClr val="E9ECF1"/>
+          </a:solidFill>
+          <a:ln>
+            <a:noFill/>
+          </a:ln>
+          <a:effectLst/>
+        </p:spPr>
+        <p:style>
+          <a:lnRef idx="1">
+            <a:schemeClr val="accent1"/>
+          </a:lnRef>
+          <a:fillRef idx="3">
+            <a:schemeClr val="accent1"/>
+          </a:fillRef>
+          <a:effectRef idx="2">
+            <a:schemeClr val="accent1"/>
+          </a:effectRef>
+          <a:fontRef idx="minor">
+            <a:schemeClr val="lt1"/>
+          </a:fontRef>
+        </p:style>
+        <p:txBody>
+          <a:bodyPr rtlCol="0" anchor="ctr" wrap="square" lIns="18288" rIns="18288" tIns="18288" bIns="18288"/>
+          <a:lstStyle/>
+          <a:p>
+            <a:pPr algn="ctr"/>
+            <a:r>
+              <a:rPr sz="1400" b="1">
+                <a:solidFill>
+                  <a:srgbClr val="6B7280"/>
+                </a:solidFill>
+                <a:latin typeface="Calibri"/>
+              </a:rPr>
+              <a:t>Upcoming</a:t>
+            </a:r>
+          </a:p>
+        </p:txBody>
+      </p:sp>
+      <p:sp>
+        <p:nvSpPr>
+          <p:cNvPr id="31" name="Rectangle 30"/>
+          <p:cNvSpPr/>
+          <p:nvPr/>
+        </p:nvSpPr>
+        <p:spPr>
+          <a:xfrm>
+            <a:off x="457200" y="5623560"/>
+            <a:ext cx="11277295" cy="640080"/>
+          </a:xfrm>
+          <a:prstGeom prst="rect">
+            <a:avLst/>
+          </a:prstGeom>
+          <a:solidFill>
+            <a:srgbClr val="E9ECF1"/>
+          </a:solidFill>
+          <a:ln>
+            <a:noFill/>
+          </a:ln>
+          <a:effectLst/>
+        </p:spPr>
+        <p:style>
+          <a:lnRef idx="1">
+            <a:schemeClr val="accent1"/>
+          </a:lnRef>
+          <a:fillRef idx="3">
+            <a:schemeClr val="accent1"/>
+          </a:fillRef>
+          <a:effectRef idx="2">
+            <a:schemeClr val="accent1"/>
+          </a:effectRef>
+          <a:fontRef idx="minor">
+            <a:schemeClr val="lt1"/>
+          </a:fontRef>
+        </p:style>
+        <p:txBody>
+          <a:bodyPr rtlCol="0" anchor="ctr"/>
+          <a:lstStyle/>
+          <a:p>
+            <a:pPr algn="ctr"/>
+          </a:p>
+        </p:txBody>
+      </p:sp>
+      <p:sp>
+        <p:nvSpPr>
+          <p:cNvPr id="32" name="Rectangle 31"/>
+          <p:cNvSpPr/>
+          <p:nvPr/>
+        </p:nvSpPr>
+        <p:spPr>
+          <a:xfrm>
+            <a:off x="457200" y="5623560"/>
+            <a:ext cx="73152" cy="640080"/>
+          </a:xfrm>
+          <a:prstGeom prst="rect">
             <a:avLst/>
           </a:prstGeom>
           <a:solidFill>
@@ -7853,32 +9002,23 @@
           </a:fontRef>
         </p:style>
         <p:txBody>
-          <a:bodyPr rtlCol="0" anchor="ctr" wrap="square" lIns="0" rIns="0" tIns="0" bIns="0"/>
+          <a:bodyPr rtlCol="0" anchor="ctr"/>
           <a:lstStyle/>
           <a:p>
             <a:pPr algn="ctr"/>
-            <a:r>
-              <a:rPr sz="2600" b="1">
-                <a:solidFill>
-                  <a:srgbClr val="FFFFFF"/>
-                </a:solidFill>
-                <a:latin typeface="Calibri"/>
-              </a:rPr>
-              <a:t>2</a:t>
-            </a:r>
-          </a:p>
-        </p:txBody>
-      </p:sp>
-      <p:sp>
-        <p:nvSpPr>
-          <p:cNvPr id="11" name="TextBox 10"/>
+          </a:p>
+        </p:txBody>
+      </p:sp>
+      <p:sp>
+        <p:nvSpPr>
+          <p:cNvPr id="33" name="TextBox 32"/>
           <p:cNvSpPr txBox="1"/>
           <p:nvPr/>
         </p:nvSpPr>
         <p:spPr>
           <a:xfrm>
-            <a:off x="1645920" y="2651760"/>
-            <a:ext cx="3017520" cy="914400"/>
+            <a:off x="640080" y="5623560"/>
+            <a:ext cx="3576218" cy="640080"/>
           </a:xfrm>
           <a:prstGeom prst="rect">
             <a:avLst/>
@@ -7891,29 +9031,29 @@
           </a:bodyPr>
           <a:lstStyle/>
           <a:p>
-            <a:pPr algn="l"/>
-            <a:r>
-              <a:rPr sz="2400" b="1">
-                <a:solidFill>
-                  <a:srgbClr val="1B263B"/>
-                </a:solidFill>
-                <a:latin typeface="Calibri"/>
-              </a:rPr>
-              <a:t>A discrepancy dataset</a:t>
-            </a:r>
-          </a:p>
-        </p:txBody>
-      </p:sp>
-      <p:sp>
-        <p:nvSpPr>
-          <p:cNvPr id="12" name="TextBox 11"/>
+            <a:pPr algn="ctr"/>
+            <a:r>
+              <a:rPr sz="1600" b="1">
+                <a:solidFill>
+                  <a:srgbClr val="1F6FB5"/>
+                </a:solidFill>
+                <a:latin typeface="Calibri"/>
+              </a:rPr>
+              <a:t>Free LLMs generate, never judge</a:t>
+            </a:r>
+          </a:p>
+        </p:txBody>
+      </p:sp>
+      <p:sp>
+        <p:nvSpPr>
+          <p:cNvPr id="34" name="TextBox 33"/>
           <p:cNvSpPr txBox="1"/>
           <p:nvPr/>
         </p:nvSpPr>
         <p:spPr>
           <a:xfrm>
-            <a:off x="4754880" y="2651760"/>
-            <a:ext cx="6796735" cy="914400"/>
+            <a:off x="4307738" y="5623560"/>
+            <a:ext cx="3576218" cy="640080"/>
           </a:xfrm>
           <a:prstGeom prst="rect">
             <a:avLst/>
@@ -7926,31 +9066,119 @@
           </a:bodyPr>
           <a:lstStyle/>
           <a:p>
+            <a:pPr algn="ctr"/>
+            <a:r>
+              <a:rPr sz="1600" b="1">
+                <a:solidFill>
+                  <a:srgbClr val="1F6FB5"/>
+                </a:solidFill>
+                <a:latin typeface="Calibri"/>
+              </a:rPr>
+              <a:t>Judge patterns, not individual findings</a:t>
+            </a:r>
+          </a:p>
+        </p:txBody>
+      </p:sp>
+      <p:sp>
+        <p:nvSpPr>
+          <p:cNvPr id="35" name="TextBox 34"/>
+          <p:cNvSpPr txBox="1"/>
+          <p:nvPr/>
+        </p:nvSpPr>
+        <p:spPr>
+          <a:xfrm>
+            <a:off x="7975396" y="5623560"/>
+            <a:ext cx="3576218" cy="640080"/>
+          </a:xfrm>
+          <a:prstGeom prst="rect">
+            <a:avLst/>
+          </a:prstGeom>
+          <a:noFill/>
+        </p:spPr>
+        <p:txBody>
+          <a:bodyPr wrap="square" anchor="ctr" lIns="45720" rIns="45720">
+            <a:spAutoFit/>
+          </a:bodyPr>
+          <a:lstStyle/>
+          <a:p>
+            <a:pPr algn="ctr"/>
+            <a:r>
+              <a:rPr sz="1600" b="1">
+                <a:solidFill>
+                  <a:srgbClr val="1F6FB5"/>
+                </a:solidFill>
+                <a:latin typeface="Calibri"/>
+              </a:rPr>
+              <a:t>Search trackers before filing</a:t>
+            </a:r>
+          </a:p>
+        </p:txBody>
+      </p:sp>
+    </p:spTree>
+  </p:cSld>
+  <p:clrMapOvr>
+    <a:masterClrMapping/>
+  </p:clrMapOvr>
+</p:sld>
+</file>
+
+<file path=ppt/slides/slide6.xml><?xml version="1.0" encoding="utf-8"?>
+<p:sld xmlns:a="http://schemas.openxmlformats.org/drawingml/2006/main" xmlns:p="http://schemas.openxmlformats.org/presentationml/2006/main" xmlns:r="http://schemas.openxmlformats.org/officeDocument/2006/relationships">
+  <p:cSld>
+    <p:spTree>
+      <p:nvGrpSpPr>
+        <p:cNvPr id="1" name=""/>
+        <p:cNvGrpSpPr/>
+        <p:nvPr/>
+      </p:nvGrpSpPr>
+      <p:grpSpPr/>
+      <p:sp>
+        <p:nvSpPr>
+          <p:cNvPr id="2" name="TextBox 1"/>
+          <p:cNvSpPr txBox="1"/>
+          <p:nvPr/>
+        </p:nvSpPr>
+        <p:spPr>
+          <a:xfrm>
+            <a:off x="640080" y="365760"/>
+            <a:ext cx="10911535" cy="685800"/>
+          </a:xfrm>
+          <a:prstGeom prst="rect">
+            <a:avLst/>
+          </a:prstGeom>
+          <a:noFill/>
+        </p:spPr>
+        <p:txBody>
+          <a:bodyPr wrap="square" anchor="ctr" lIns="45720" rIns="45720">
+            <a:spAutoFit/>
+          </a:bodyPr>
+          <a:lstStyle/>
+          <a:p>
             <a:pPr algn="l"/>
             <a:r>
-              <a:rPr sz="1800" b="0">
+              <a:rPr sz="3400" b="1">
                 <a:solidFill>
                   <a:srgbClr val="1B263B"/>
                 </a:solidFill>
                 <a:latin typeface="Calibri"/>
               </a:rPr>
-              <a:t>Disagreements classified as real bug, intended, known or harness noise, with evidence, reusable by others.</a:t>
-            </a:r>
-          </a:p>
-        </p:txBody>
-      </p:sp>
-      <p:sp>
-        <p:nvSpPr>
-          <p:cNvPr id="13" name="Oval 12"/>
+              <a:t>Updates: what is done so far</a:t>
+            </a:r>
+          </a:p>
+        </p:txBody>
+      </p:sp>
+      <p:sp>
+        <p:nvSpPr>
+          <p:cNvPr id="3" name="Rectangle 2"/>
           <p:cNvSpPr/>
           <p:nvPr/>
         </p:nvSpPr>
         <p:spPr>
           <a:xfrm>
-            <a:off x="685800" y="3977640"/>
-            <a:ext cx="640080" cy="640080"/>
-          </a:xfrm>
-          <a:prstGeom prst="ellipse">
+            <a:off x="685800" y="1051560"/>
+            <a:ext cx="822960" cy="54864"/>
+          </a:xfrm>
+          <a:prstGeom prst="rect">
             <a:avLst/>
           </a:prstGeom>
           <a:solidFill>
@@ -7976,108 +9204,29 @@
           </a:fontRef>
         </p:style>
         <p:txBody>
-          <a:bodyPr rtlCol="0" anchor="ctr" wrap="square" lIns="0" rIns="0" tIns="0" bIns="0"/>
+          <a:bodyPr rtlCol="0" anchor="ctr"/>
           <a:lstStyle/>
           <a:p>
             <a:pPr algn="ctr"/>
-            <a:r>
-              <a:rPr sz="2600" b="1">
-                <a:solidFill>
-                  <a:srgbClr val="FFFFFF"/>
-                </a:solidFill>
-                <a:latin typeface="Calibri"/>
-              </a:rPr>
-              <a:t>3</a:t>
-            </a:r>
-          </a:p>
-        </p:txBody>
-      </p:sp>
-      <p:sp>
-        <p:nvSpPr>
-          <p:cNvPr id="14" name="TextBox 13"/>
-          <p:cNvSpPr txBox="1"/>
-          <p:nvPr/>
-        </p:nvSpPr>
-        <p:spPr>
-          <a:xfrm>
-            <a:off x="1645920" y="3840480"/>
-            <a:ext cx="3017520" cy="914400"/>
+          </a:p>
+        </p:txBody>
+      </p:sp>
+      <p:sp>
+        <p:nvSpPr>
+          <p:cNvPr id="4" name="Rectangle 3"/>
+          <p:cNvSpPr/>
+          <p:nvPr/>
+        </p:nvSpPr>
+        <p:spPr>
+          <a:xfrm>
+            <a:off x="685800" y="6400800"/>
+            <a:ext cx="10865815" cy="9144"/>
           </a:xfrm>
           <a:prstGeom prst="rect">
             <a:avLst/>
           </a:prstGeom>
-          <a:noFill/>
-        </p:spPr>
-        <p:txBody>
-          <a:bodyPr wrap="square" anchor="ctr" lIns="45720" rIns="45720">
-            <a:spAutoFit/>
-          </a:bodyPr>
-          <a:lstStyle/>
-          <a:p>
-            <a:pPr algn="l"/>
-            <a:r>
-              <a:rPr sz="2400" b="1">
-                <a:solidFill>
-                  <a:srgbClr val="1B263B"/>
-                </a:solidFill>
-                <a:latin typeface="Calibri"/>
-              </a:rPr>
-              <a:t>A reusable pipeline</a:t>
-            </a:r>
-          </a:p>
-        </p:txBody>
-      </p:sp>
-      <p:sp>
-        <p:nvSpPr>
-          <p:cNvPr id="15" name="TextBox 14"/>
-          <p:cNvSpPr txBox="1"/>
-          <p:nvPr/>
-        </p:nvSpPr>
-        <p:spPr>
-          <a:xfrm>
-            <a:off x="4754880" y="3840480"/>
-            <a:ext cx="6796735" cy="914400"/>
-          </a:xfrm>
-          <a:prstGeom prst="rect">
-            <a:avLst/>
-          </a:prstGeom>
-          <a:noFill/>
-        </p:spPr>
-        <p:txBody>
-          <a:bodyPr wrap="square" anchor="ctr" lIns="45720" rIns="45720">
-            <a:spAutoFit/>
-          </a:bodyPr>
-          <a:lstStyle/>
-          <a:p>
-            <a:pPr algn="l"/>
-            <a:r>
-              <a:rPr sz="1800" b="0">
-                <a:solidFill>
-                  <a:srgbClr val="1B263B"/>
-                </a:solidFill>
-                <a:latin typeface="Calibri"/>
-              </a:rPr>
-              <a:t>Knowledge base and triage discard known differences cheaply, so humans review only real candidates. Funnel numbers: programs, disagreements, candidates, confirmed, filed.</a:t>
-            </a:r>
-          </a:p>
-        </p:txBody>
-      </p:sp>
-      <p:sp>
-        <p:nvSpPr>
-          <p:cNvPr id="16" name="Rectangle 15"/>
-          <p:cNvSpPr/>
-          <p:nvPr/>
-        </p:nvSpPr>
-        <p:spPr>
-          <a:xfrm>
-            <a:off x="685800" y="5212080"/>
-            <a:ext cx="10865815" cy="822960"/>
-          </a:xfrm>
-          <a:prstGeom prst="rect">
-            <a:avLst/>
-          </a:prstGeom>
           <a:solidFill>
-            <a:srgbClr val="E9ECF1"/>
+            <a:srgbClr val="C9CFD8"/>
           </a:solidFill>
           <a:ln>
             <a:noFill/>
@@ -8108,14 +9257,340 @@
       </p:sp>
       <p:sp>
         <p:nvSpPr>
-          <p:cNvPr id="17" name="Rectangle 16"/>
+          <p:cNvPr id="5" name="TextBox 4"/>
+          <p:cNvSpPr txBox="1"/>
+          <p:nvPr/>
+        </p:nvSpPr>
+        <p:spPr>
+          <a:xfrm>
+            <a:off x="640080" y="6428232"/>
+            <a:ext cx="3657600" cy="320040"/>
+          </a:xfrm>
+          <a:prstGeom prst="rect">
+            <a:avLst/>
+          </a:prstGeom>
+          <a:noFill/>
+        </p:spPr>
+        <p:txBody>
+          <a:bodyPr wrap="square" anchor="t" lIns="45720" rIns="45720">
+            <a:spAutoFit/>
+          </a:bodyPr>
+          <a:lstStyle/>
+          <a:p>
+            <a:pPr algn="l"/>
+            <a:r>
+              <a:rPr sz="1200" b="0">
+                <a:solidFill>
+                  <a:srgbClr val="6B7280"/>
+                </a:solidFill>
+                <a:latin typeface="Calibri"/>
+              </a:rPr>
+              <a:t>typediff</a:t>
+            </a:r>
+          </a:p>
+        </p:txBody>
+      </p:sp>
+      <p:sp>
+        <p:nvSpPr>
+          <p:cNvPr id="6" name="TextBox 5"/>
+          <p:cNvSpPr txBox="1"/>
+          <p:nvPr/>
+        </p:nvSpPr>
+        <p:spPr>
+          <a:xfrm>
+            <a:off x="10637215" y="6428232"/>
+            <a:ext cx="914400" cy="320040"/>
+          </a:xfrm>
+          <a:prstGeom prst="rect">
+            <a:avLst/>
+          </a:prstGeom>
+          <a:noFill/>
+        </p:spPr>
+        <p:txBody>
+          <a:bodyPr wrap="square" anchor="t" lIns="45720" rIns="45720">
+            <a:spAutoFit/>
+          </a:bodyPr>
+          <a:lstStyle/>
+          <a:p>
+            <a:pPr algn="r"/>
+            <a:r>
+              <a:rPr sz="1200" b="0">
+                <a:solidFill>
+                  <a:srgbClr val="6B7280"/>
+                </a:solidFill>
+                <a:latin typeface="Calibri"/>
+              </a:rPr>
+              <a:t>6</a:t>
+            </a:r>
+          </a:p>
+        </p:txBody>
+      </p:sp>
+      <p:sp>
+        <p:nvSpPr>
+          <p:cNvPr id="7" name="TextBox 6"/>
+          <p:cNvSpPr txBox="1"/>
+          <p:nvPr/>
+        </p:nvSpPr>
+        <p:spPr>
+          <a:xfrm>
+            <a:off x="640080" y="1325880"/>
+            <a:ext cx="7498079" cy="4937760"/>
+          </a:xfrm>
+          <a:prstGeom prst="rect">
+            <a:avLst/>
+          </a:prstGeom>
+          <a:noFill/>
+        </p:spPr>
+        <p:txBody>
+          <a:bodyPr wrap="square">
+            <a:spAutoFit/>
+          </a:bodyPr>
+          <a:lstStyle/>
+          <a:p>
+            <a:r>
+              <a:rPr sz="1700" b="1">
+                <a:solidFill>
+                  <a:srgbClr val="1F6FB5"/>
+                </a:solidFill>
+                <a:latin typeface="Calibri"/>
+              </a:rPr>
+              <a:t>▪  </a:t>
+            </a:r>
+            <a:r>
+              <a:rPr sz="1700" b="1">
+                <a:solidFill>
+                  <a:srgbClr val="1B263B"/>
+                </a:solidFill>
+                <a:latin typeface="Calibri"/>
+              </a:rPr>
+              <a:t>Pipeline built end to end: </a:t>
+            </a:r>
+            <a:r>
+              <a:rPr sz="1700" b="0">
+                <a:solidFill>
+                  <a:srgbClr val="1B263B"/>
+                </a:solidFill>
+                <a:latin typeface="Calibri"/>
+              </a:rPr>
+              <a:t>runs mypy, ty, pyright and CPython, normalises output, detects disagreements, auto-dismisses known ones with a knowledge base, groups the rest into patterns.</a:t>
+            </a:r>
+          </a:p>
+          <a:p>
+            <a:pPr>
+              <a:spcBef>
+                <a:spcPts val="900"/>
+              </a:spcBef>
+            </a:pPr>
+            <a:r>
+              <a:rPr sz="1700" b="1">
+                <a:solidFill>
+                  <a:srgbClr val="1F6FB5"/>
+                </a:solidFill>
+                <a:latin typeface="Calibri"/>
+              </a:rPr>
+              <a:t>▪  </a:t>
+            </a:r>
+            <a:r>
+              <a:rPr sz="1700" b="1">
+                <a:solidFill>
+                  <a:srgbClr val="1B263B"/>
+                </a:solidFill>
+                <a:latin typeface="Calibri"/>
+              </a:rPr>
+              <a:t>First probe: </a:t>
+            </a:r>
+            <a:r>
+              <a:rPr sz="1700" b="0">
+                <a:solidFill>
+                  <a:srgbClr val="1B263B"/>
+                </a:solidFill>
+                <a:latin typeface="Calibri"/>
+              </a:rPr>
+              <a:t>a hand-written Self seed led to our first report (ty#4656). Closed as intended; a related display bug is ty#4673. Lesson: argue the accused tool's side before filing.</a:t>
+            </a:r>
+          </a:p>
+          <a:p>
+            <a:pPr>
+              <a:spcBef>
+                <a:spcPts val="900"/>
+              </a:spcBef>
+            </a:pPr>
+            <a:r>
+              <a:rPr sz="1700" b="1">
+                <a:solidFill>
+                  <a:srgbClr val="1F6FB5"/>
+                </a:solidFill>
+                <a:latin typeface="Calibri"/>
+              </a:rPr>
+              <a:t>▪  </a:t>
+            </a:r>
+            <a:r>
+              <a:rPr sz="1700" b="1">
+                <a:solidFill>
+                  <a:srgbClr val="1B263B"/>
+                </a:solidFill>
+                <a:latin typeface="Calibri"/>
+              </a:rPr>
+              <a:t>Corpus: </a:t>
+            </a:r>
+            <a:r>
+              <a:rPr sz="1700" b="0">
+                <a:solidFill>
+                  <a:srgbClr val="1B263B"/>
+                </a:solidFill>
+                <a:latin typeface="Calibri"/>
+              </a:rPr>
+              <a:t>27 hand-written seeds plus 4,849 harvested programs (typing conformance suite, ty mdtests, mypy tests).</a:t>
+            </a:r>
+          </a:p>
+          <a:p>
+            <a:pPr>
+              <a:spcBef>
+                <a:spcPts val="900"/>
+              </a:spcBef>
+            </a:pPr>
+            <a:r>
+              <a:rPr sz="1700" b="1">
+                <a:solidFill>
+                  <a:srgbClr val="1F6FB5"/>
+                </a:solidFill>
+                <a:latin typeface="Calibri"/>
+              </a:rPr>
+              <a:t>▪  </a:t>
+            </a:r>
+            <a:r>
+              <a:rPr sz="1700" b="1">
+                <a:solidFill>
+                  <a:srgbClr val="1B263B"/>
+                </a:solidFill>
+                <a:latin typeface="Calibri"/>
+              </a:rPr>
+              <a:t>First full run: </a:t>
+            </a:r>
+            <a:r>
+              <a:rPr sz="1700" b="0">
+                <a:solidFill>
+                  <a:srgbClr val="1B263B"/>
+                </a:solidFill>
+                <a:latin typeface="Calibri"/>
+              </a:rPr>
+              <a:t>7,480 findings in 618 patterns, all deterministic, no LLM.</a:t>
+            </a:r>
+          </a:p>
+          <a:p>
+            <a:pPr>
+              <a:spcBef>
+                <a:spcPts val="900"/>
+              </a:spcBef>
+            </a:pPr>
+            <a:r>
+              <a:rPr sz="1700" b="1">
+                <a:solidFill>
+                  <a:srgbClr val="1F6FB5"/>
+                </a:solidFill>
+                <a:latin typeface="Calibri"/>
+              </a:rPr>
+              <a:t>▪  </a:t>
+            </a:r>
+            <a:r>
+              <a:rPr sz="1700" b="1">
+                <a:solidFill>
+                  <a:srgbClr val="1B263B"/>
+                </a:solidFill>
+                <a:latin typeface="Calibri"/>
+              </a:rPr>
+              <a:t>Triage of top 5 patterns: </a:t>
+            </a:r>
+            <a:r>
+              <a:rPr sz="1700" b="0">
+                <a:solidFill>
+                  <a:srgbClr val="1B263B"/>
+                </a:solidFill>
+                <a:latin typeface="Calibri"/>
+              </a:rPr>
+              <a:t>all harness noise or design differences, no new bug yet. It showed our 'strong bug evidence' flag was misleading.</a:t>
+            </a:r>
+          </a:p>
+          <a:p>
+            <a:pPr>
+              <a:spcBef>
+                <a:spcPts val="900"/>
+              </a:spcBef>
+            </a:pPr>
+            <a:r>
+              <a:rPr sz="1700" b="1">
+                <a:solidFill>
+                  <a:srgbClr val="1F6FB5"/>
+                </a:solidFill>
+                <a:latin typeface="Calibri"/>
+              </a:rPr>
+              <a:t>▪  </a:t>
+            </a:r>
+            <a:r>
+              <a:rPr sz="1700" b="1">
+                <a:solidFill>
+                  <a:srgbClr val="1B263B"/>
+                </a:solidFill>
+                <a:latin typeface="Calibri"/>
+              </a:rPr>
+              <a:t>Pipeline fixes: </a:t>
+            </a:r>
+            <a:r>
+              <a:rPr sz="1700" b="0">
+                <a:solidFill>
+                  <a:srgbClr val="1B263B"/>
+                </a:solidFill>
+                <a:latin typeface="Calibri"/>
+              </a:rPr>
+              <a:t>NameError no longer blames the silent tool, stub-function None ignored, runtime-miss anchored on full statement, 4 scoped KB entries, harvest provenance, 1,423 other-version mdtest snippets skipped. 81 tests pass.</a:t>
+            </a:r>
+          </a:p>
+          <a:p>
+            <a:pPr>
+              <a:spcBef>
+                <a:spcPts val="900"/>
+              </a:spcBef>
+            </a:pPr>
+            <a:r>
+              <a:rPr sz="1700" b="1">
+                <a:solidFill>
+                  <a:srgbClr val="1F6FB5"/>
+                </a:solidFill>
+                <a:latin typeface="Calibri"/>
+              </a:rPr>
+              <a:t>▪  </a:t>
+            </a:r>
+            <a:r>
+              <a:rPr sz="1700" b="1">
+                <a:solidFill>
+                  <a:srgbClr val="1B263B"/>
+                </a:solidFill>
+                <a:latin typeface="Calibri"/>
+              </a:rPr>
+              <a:t>In progress: </a:t>
+            </a:r>
+            <a:r>
+              <a:rPr sz="1700" b="0">
+                <a:solidFill>
+                  <a:srgbClr val="1B263B"/>
+                </a:solidFill>
+                <a:latin typeface="Calibri"/>
+              </a:rPr>
+              <a:t>re-run on the fixed pipeline.</a:t>
+            </a:r>
+          </a:p>
+        </p:txBody>
+      </p:sp>
+      <p:sp>
+        <p:nvSpPr>
+          <p:cNvPr id="8" name="Rectangle 7"/>
           <p:cNvSpPr/>
           <p:nvPr/>
         </p:nvSpPr>
         <p:spPr>
           <a:xfrm>
-            <a:off x="685800" y="5212080"/>
-            <a:ext cx="73152" cy="822960"/>
+            <a:off x="8503920" y="1600200"/>
+            <a:ext cx="3063240" cy="914400"/>
           </a:xfrm>
           <a:prstGeom prst="rect">
             <a:avLst/>
@@ -8143,23 +9618,257 @@
           </a:fontRef>
         </p:style>
         <p:txBody>
-          <a:bodyPr rtlCol="0" anchor="ctr"/>
+          <a:bodyPr rtlCol="0" anchor="ctr" wrap="square" lIns="27432" rIns="27432" tIns="27432" bIns="27432"/>
           <a:lstStyle/>
           <a:p>
             <a:pPr algn="ctr"/>
-          </a:p>
-        </p:txBody>
-      </p:sp>
-      <p:sp>
-        <p:nvSpPr>
-          <p:cNvPr id="18" name="TextBox 17"/>
+            <a:r>
+              <a:rPr sz="2400" b="1">
+                <a:solidFill>
+                  <a:srgbClr val="FFFFFF"/>
+                </a:solidFill>
+                <a:latin typeface="Calibri"/>
+              </a:rPr>
+              <a:t>7,480</a:t>
+            </a:r>
+          </a:p>
+          <a:p>
+            <a:pPr algn="ctr"/>
+            <a:r>
+              <a:rPr sz="1400" b="0">
+                <a:solidFill>
+                  <a:srgbClr val="FFFFFF"/>
+                </a:solidFill>
+                <a:latin typeface="Calibri"/>
+              </a:rPr>
+              <a:t>findings</a:t>
+            </a:r>
+          </a:p>
+        </p:txBody>
+      </p:sp>
+      <p:sp>
+        <p:nvSpPr>
+          <p:cNvPr id="9" name="Rectangle 8"/>
+          <p:cNvSpPr/>
+          <p:nvPr/>
+        </p:nvSpPr>
+        <p:spPr>
+          <a:xfrm>
+            <a:off x="8810244" y="2697480"/>
+            <a:ext cx="2450592" cy="914400"/>
+          </a:xfrm>
+          <a:prstGeom prst="rect">
+            <a:avLst/>
+          </a:prstGeom>
+          <a:solidFill>
+            <a:srgbClr val="1F6FB5"/>
+          </a:solidFill>
+          <a:ln>
+            <a:noFill/>
+          </a:ln>
+          <a:effectLst/>
+        </p:spPr>
+        <p:style>
+          <a:lnRef idx="1">
+            <a:schemeClr val="accent1"/>
+          </a:lnRef>
+          <a:fillRef idx="3">
+            <a:schemeClr val="accent1"/>
+          </a:fillRef>
+          <a:effectRef idx="2">
+            <a:schemeClr val="accent1"/>
+          </a:effectRef>
+          <a:fontRef idx="minor">
+            <a:schemeClr val="lt1"/>
+          </a:fontRef>
+        </p:style>
+        <p:txBody>
+          <a:bodyPr rtlCol="0" anchor="ctr" wrap="square" lIns="27432" rIns="27432" tIns="27432" bIns="27432"/>
+          <a:lstStyle/>
+          <a:p>
+            <a:pPr algn="ctr"/>
+            <a:r>
+              <a:rPr sz="2400" b="1">
+                <a:solidFill>
+                  <a:srgbClr val="FFFFFF"/>
+                </a:solidFill>
+                <a:latin typeface="Calibri"/>
+              </a:rPr>
+              <a:t>618</a:t>
+            </a:r>
+          </a:p>
+          <a:p>
+            <a:pPr algn="ctr"/>
+            <a:r>
+              <a:rPr sz="1400" b="0">
+                <a:solidFill>
+                  <a:srgbClr val="FFFFFF"/>
+                </a:solidFill>
+                <a:latin typeface="Calibri"/>
+              </a:rPr>
+              <a:t>patterns</a:t>
+            </a:r>
+          </a:p>
+        </p:txBody>
+      </p:sp>
+      <p:sp>
+        <p:nvSpPr>
+          <p:cNvPr id="10" name="Rectangle 9"/>
+          <p:cNvSpPr/>
+          <p:nvPr/>
+        </p:nvSpPr>
+        <p:spPr>
+          <a:xfrm>
+            <a:off x="9085935" y="3794760"/>
+            <a:ext cx="1899208" cy="914400"/>
+          </a:xfrm>
+          <a:prstGeom prst="rect">
+            <a:avLst/>
+          </a:prstGeom>
+          <a:solidFill>
+            <a:srgbClr val="1F6FB5"/>
+          </a:solidFill>
+          <a:ln>
+            <a:noFill/>
+          </a:ln>
+          <a:effectLst/>
+        </p:spPr>
+        <p:style>
+          <a:lnRef idx="1">
+            <a:schemeClr val="accent1"/>
+          </a:lnRef>
+          <a:fillRef idx="3">
+            <a:schemeClr val="accent1"/>
+          </a:fillRef>
+          <a:effectRef idx="2">
+            <a:schemeClr val="accent1"/>
+          </a:effectRef>
+          <a:fontRef idx="minor">
+            <a:schemeClr val="lt1"/>
+          </a:fontRef>
+        </p:style>
+        <p:txBody>
+          <a:bodyPr rtlCol="0" anchor="ctr" wrap="square" lIns="27432" rIns="27432" tIns="27432" bIns="27432"/>
+          <a:lstStyle/>
+          <a:p>
+            <a:pPr algn="ctr"/>
+            <a:r>
+              <a:rPr sz="2400" b="1">
+                <a:solidFill>
+                  <a:srgbClr val="FFFFFF"/>
+                </a:solidFill>
+                <a:latin typeface="Calibri"/>
+              </a:rPr>
+              <a:t>5</a:t>
+            </a:r>
+          </a:p>
+          <a:p>
+            <a:pPr algn="ctr"/>
+            <a:r>
+              <a:rPr sz="1400" b="0">
+                <a:solidFill>
+                  <a:srgbClr val="FFFFFF"/>
+                </a:solidFill>
+                <a:latin typeface="Calibri"/>
+              </a:rPr>
+              <a:t>top patterns triaged</a:t>
+            </a:r>
+          </a:p>
+        </p:txBody>
+      </p:sp>
+      <p:sp>
+        <p:nvSpPr>
+          <p:cNvPr id="11" name="Rectangle 10"/>
+          <p:cNvSpPr/>
+          <p:nvPr/>
+        </p:nvSpPr>
+        <p:spPr>
+          <a:xfrm>
+            <a:off x="9330994" y="4892040"/>
+            <a:ext cx="1409090" cy="914400"/>
+          </a:xfrm>
+          <a:prstGeom prst="rect">
+            <a:avLst/>
+          </a:prstGeom>
+          <a:solidFill>
+            <a:srgbClr val="1B263B"/>
+          </a:solidFill>
+          <a:ln>
+            <a:noFill/>
+          </a:ln>
+          <a:effectLst/>
+        </p:spPr>
+        <p:style>
+          <a:lnRef idx="1">
+            <a:schemeClr val="accent1"/>
+          </a:lnRef>
+          <a:fillRef idx="3">
+            <a:schemeClr val="accent1"/>
+          </a:fillRef>
+          <a:effectRef idx="2">
+            <a:schemeClr val="accent1"/>
+          </a:effectRef>
+          <a:fontRef idx="minor">
+            <a:schemeClr val="lt1"/>
+          </a:fontRef>
+        </p:style>
+        <p:txBody>
+          <a:bodyPr rtlCol="0" anchor="ctr" wrap="square" lIns="27432" rIns="27432" tIns="27432" bIns="27432"/>
+          <a:lstStyle/>
+          <a:p>
+            <a:pPr algn="ctr"/>
+            <a:r>
+              <a:rPr sz="2400" b="1">
+                <a:solidFill>
+                  <a:srgbClr val="FFFFFF"/>
+                </a:solidFill>
+                <a:latin typeface="Calibri"/>
+              </a:rPr>
+              <a:t>0</a:t>
+            </a:r>
+          </a:p>
+          <a:p>
+            <a:pPr algn="ctr"/>
+            <a:r>
+              <a:rPr sz="1400" b="0">
+                <a:solidFill>
+                  <a:srgbClr val="FFFFFF"/>
+                </a:solidFill>
+                <a:latin typeface="Calibri"/>
+              </a:rPr>
+              <a:t>confirmed bugs yet</a:t>
+            </a:r>
+          </a:p>
+        </p:txBody>
+      </p:sp>
+    </p:spTree>
+  </p:cSld>
+  <p:clrMapOvr>
+    <a:masterClrMapping/>
+  </p:clrMapOvr>
+</p:sld>
+</file>
+
+<file path=ppt/slides/slide7.xml><?xml version="1.0" encoding="utf-8"?>
+<p:sld xmlns:a="http://schemas.openxmlformats.org/drawingml/2006/main" xmlns:p="http://schemas.openxmlformats.org/presentationml/2006/main" xmlns:r="http://schemas.openxmlformats.org/officeDocument/2006/relationships">
+  <p:cSld>
+    <p:spTree>
+      <p:nvGrpSpPr>
+        <p:cNvPr id="1" name=""/>
+        <p:cNvGrpSpPr/>
+        <p:nvPr/>
+      </p:nvGrpSpPr>
+      <p:grpSpPr/>
+      <p:sp>
+        <p:nvSpPr>
+          <p:cNvPr id="2" name="TextBox 1"/>
           <p:cNvSpPr txBox="1"/>
           <p:nvPr/>
         </p:nvSpPr>
         <p:spPr>
           <a:xfrm>
-            <a:off x="914400" y="5212080"/>
-            <a:ext cx="10454335" cy="822960"/>
+            <a:off x="640080" y="365760"/>
+            <a:ext cx="10911535" cy="685800"/>
           </a:xfrm>
           <a:prstGeom prst="rect">
             <a:avLst/>
@@ -8174,27 +9883,238 @@
           <a:p>
             <a:pPr algn="l"/>
             <a:r>
-              <a:rPr sz="1800" b="1">
-                <a:solidFill>
-                  <a:srgbClr val="1F6FB5"/>
-                </a:solidFill>
-                <a:latin typeface="Calibri"/>
-              </a:rPr>
-              <a:t>Status so far: </a:t>
-            </a:r>
-          </a:p>
-        </p:txBody>
-      </p:sp>
-      <p:sp>
-        <p:nvSpPr>
-          <p:cNvPr id="19" name="TextBox 18"/>
+              <a:rPr sz="3400" b="1">
+                <a:solidFill>
+                  <a:srgbClr val="1B263B"/>
+                </a:solidFill>
+                <a:latin typeface="Calibri"/>
+              </a:rPr>
+              <a:t>Expected outcomes</a:t>
+            </a:r>
+          </a:p>
+        </p:txBody>
+      </p:sp>
+      <p:sp>
+        <p:nvSpPr>
+          <p:cNvPr id="3" name="Rectangle 2"/>
+          <p:cNvSpPr/>
+          <p:nvPr/>
+        </p:nvSpPr>
+        <p:spPr>
+          <a:xfrm>
+            <a:off x="685800" y="1051560"/>
+            <a:ext cx="822960" cy="54864"/>
+          </a:xfrm>
+          <a:prstGeom prst="rect">
+            <a:avLst/>
+          </a:prstGeom>
+          <a:solidFill>
+            <a:srgbClr val="1F6FB5"/>
+          </a:solidFill>
+          <a:ln>
+            <a:noFill/>
+          </a:ln>
+          <a:effectLst/>
+        </p:spPr>
+        <p:style>
+          <a:lnRef idx="1">
+            <a:schemeClr val="accent1"/>
+          </a:lnRef>
+          <a:fillRef idx="3">
+            <a:schemeClr val="accent1"/>
+          </a:fillRef>
+          <a:effectRef idx="2">
+            <a:schemeClr val="accent1"/>
+          </a:effectRef>
+          <a:fontRef idx="minor">
+            <a:schemeClr val="lt1"/>
+          </a:fontRef>
+        </p:style>
+        <p:txBody>
+          <a:bodyPr rtlCol="0" anchor="ctr"/>
+          <a:lstStyle/>
+          <a:p>
+            <a:pPr algn="ctr"/>
+          </a:p>
+        </p:txBody>
+      </p:sp>
+      <p:sp>
+        <p:nvSpPr>
+          <p:cNvPr id="4" name="Rectangle 3"/>
+          <p:cNvSpPr/>
+          <p:nvPr/>
+        </p:nvSpPr>
+        <p:spPr>
+          <a:xfrm>
+            <a:off x="685800" y="6400800"/>
+            <a:ext cx="10865815" cy="9144"/>
+          </a:xfrm>
+          <a:prstGeom prst="rect">
+            <a:avLst/>
+          </a:prstGeom>
+          <a:solidFill>
+            <a:srgbClr val="C9CFD8"/>
+          </a:solidFill>
+          <a:ln>
+            <a:noFill/>
+          </a:ln>
+          <a:effectLst/>
+        </p:spPr>
+        <p:style>
+          <a:lnRef idx="1">
+            <a:schemeClr val="accent1"/>
+          </a:lnRef>
+          <a:fillRef idx="3">
+            <a:schemeClr val="accent1"/>
+          </a:fillRef>
+          <a:effectRef idx="2">
+            <a:schemeClr val="accent1"/>
+          </a:effectRef>
+          <a:fontRef idx="minor">
+            <a:schemeClr val="lt1"/>
+          </a:fontRef>
+        </p:style>
+        <p:txBody>
+          <a:bodyPr rtlCol="0" anchor="ctr"/>
+          <a:lstStyle/>
+          <a:p>
+            <a:pPr algn="ctr"/>
+          </a:p>
+        </p:txBody>
+      </p:sp>
+      <p:sp>
+        <p:nvSpPr>
+          <p:cNvPr id="5" name="TextBox 4"/>
           <p:cNvSpPr txBox="1"/>
           <p:nvPr/>
         </p:nvSpPr>
         <p:spPr>
           <a:xfrm>
-            <a:off x="2651760" y="5212080"/>
-            <a:ext cx="8716975" cy="822960"/>
+            <a:off x="640080" y="6428232"/>
+            <a:ext cx="3657600" cy="320040"/>
+          </a:xfrm>
+          <a:prstGeom prst="rect">
+            <a:avLst/>
+          </a:prstGeom>
+          <a:noFill/>
+        </p:spPr>
+        <p:txBody>
+          <a:bodyPr wrap="square" anchor="t" lIns="45720" rIns="45720">
+            <a:spAutoFit/>
+          </a:bodyPr>
+          <a:lstStyle/>
+          <a:p>
+            <a:pPr algn="l"/>
+            <a:r>
+              <a:rPr sz="1200" b="0">
+                <a:solidFill>
+                  <a:srgbClr val="6B7280"/>
+                </a:solidFill>
+                <a:latin typeface="Calibri"/>
+              </a:rPr>
+              <a:t>typediff</a:t>
+            </a:r>
+          </a:p>
+        </p:txBody>
+      </p:sp>
+      <p:sp>
+        <p:nvSpPr>
+          <p:cNvPr id="6" name="TextBox 5"/>
+          <p:cNvSpPr txBox="1"/>
+          <p:nvPr/>
+        </p:nvSpPr>
+        <p:spPr>
+          <a:xfrm>
+            <a:off x="10637215" y="6428232"/>
+            <a:ext cx="914400" cy="320040"/>
+          </a:xfrm>
+          <a:prstGeom prst="rect">
+            <a:avLst/>
+          </a:prstGeom>
+          <a:noFill/>
+        </p:spPr>
+        <p:txBody>
+          <a:bodyPr wrap="square" anchor="t" lIns="45720" rIns="45720">
+            <a:spAutoFit/>
+          </a:bodyPr>
+          <a:lstStyle/>
+          <a:p>
+            <a:pPr algn="r"/>
+            <a:r>
+              <a:rPr sz="1200" b="0">
+                <a:solidFill>
+                  <a:srgbClr val="6B7280"/>
+                </a:solidFill>
+                <a:latin typeface="Calibri"/>
+              </a:rPr>
+              <a:t>7</a:t>
+            </a:r>
+          </a:p>
+        </p:txBody>
+      </p:sp>
+      <p:sp>
+        <p:nvSpPr>
+          <p:cNvPr id="7" name="Oval 6"/>
+          <p:cNvSpPr/>
+          <p:nvPr/>
+        </p:nvSpPr>
+        <p:spPr>
+          <a:xfrm>
+            <a:off x="685800" y="1600200"/>
+            <a:ext cx="640080" cy="640080"/>
+          </a:xfrm>
+          <a:prstGeom prst="ellipse">
+            <a:avLst/>
+          </a:prstGeom>
+          <a:solidFill>
+            <a:srgbClr val="1F6FB5"/>
+          </a:solidFill>
+          <a:ln>
+            <a:noFill/>
+          </a:ln>
+          <a:effectLst/>
+        </p:spPr>
+        <p:style>
+          <a:lnRef idx="1">
+            <a:schemeClr val="accent1"/>
+          </a:lnRef>
+          <a:fillRef idx="3">
+            <a:schemeClr val="accent1"/>
+          </a:fillRef>
+          <a:effectRef idx="2">
+            <a:schemeClr val="accent1"/>
+          </a:effectRef>
+          <a:fontRef idx="minor">
+            <a:schemeClr val="lt1"/>
+          </a:fontRef>
+        </p:style>
+        <p:txBody>
+          <a:bodyPr rtlCol="0" anchor="ctr" wrap="square" lIns="0" rIns="0" tIns="0" bIns="0"/>
+          <a:lstStyle/>
+          <a:p>
+            <a:pPr algn="ctr"/>
+            <a:r>
+              <a:rPr sz="2600" b="1">
+                <a:solidFill>
+                  <a:srgbClr val="FFFFFF"/>
+                </a:solidFill>
+                <a:latin typeface="Calibri"/>
+              </a:rPr>
+              <a:t>1</a:t>
+            </a:r>
+          </a:p>
+        </p:txBody>
+      </p:sp>
+      <p:sp>
+        <p:nvSpPr>
+          <p:cNvPr id="8" name="TextBox 7"/>
+          <p:cNvSpPr txBox="1"/>
+          <p:nvPr/>
+        </p:nvSpPr>
+        <p:spPr>
+          <a:xfrm>
+            <a:off x="1645920" y="1463040"/>
+            <a:ext cx="3017520" cy="914400"/>
           </a:xfrm>
           <a:prstGeom prst="rect">
             <a:avLst/>
@@ -8209,13 +10129,294 @@
           <a:p>
             <a:pPr algn="l"/>
             <a:r>
+              <a:rPr sz="2400" b="1">
+                <a:solidFill>
+                  <a:srgbClr val="1B263B"/>
+                </a:solidFill>
+                <a:latin typeface="Calibri"/>
+              </a:rPr>
+              <a:t>New, confirmed bugs</a:t>
+            </a:r>
+          </a:p>
+        </p:txBody>
+      </p:sp>
+      <p:sp>
+        <p:nvSpPr>
+          <p:cNvPr id="9" name="TextBox 8"/>
+          <p:cNvSpPr txBox="1"/>
+          <p:nvPr/>
+        </p:nvSpPr>
+        <p:spPr>
+          <a:xfrm>
+            <a:off x="4754880" y="1463040"/>
+            <a:ext cx="6796735" cy="914400"/>
+          </a:xfrm>
+          <a:prstGeom prst="rect">
+            <a:avLst/>
+          </a:prstGeom>
+          <a:noFill/>
+        </p:spPr>
+        <p:txBody>
+          <a:bodyPr wrap="square" anchor="ctr" lIns="45720" rIns="45720">
+            <a:spAutoFit/>
+          </a:bodyPr>
+          <a:lstStyle/>
+          <a:p>
+            <a:pPr algn="l"/>
+            <a:r>
               <a:rPr sz="1800" b="0">
                 <a:solidFill>
                   <a:srgbClr val="1B263B"/>
                 </a:solidFill>
                 <a:latin typeface="Calibri"/>
               </a:rPr>
-              <a:t>pipeline built, first corpus of 4,849 programs run, triage and fixes in progress</a:t>
+              <a:t>Reportable bugs in ty (and mypy): minimal repros filed upstream with spec references, checked against the trackers for duplicates.</a:t>
+            </a:r>
+          </a:p>
+        </p:txBody>
+      </p:sp>
+      <p:sp>
+        <p:nvSpPr>
+          <p:cNvPr id="10" name="Oval 9"/>
+          <p:cNvSpPr/>
+          <p:nvPr/>
+        </p:nvSpPr>
+        <p:spPr>
+          <a:xfrm>
+            <a:off x="685800" y="2788920"/>
+            <a:ext cx="640080" cy="640080"/>
+          </a:xfrm>
+          <a:prstGeom prst="ellipse">
+            <a:avLst/>
+          </a:prstGeom>
+          <a:solidFill>
+            <a:srgbClr val="1F6FB5"/>
+          </a:solidFill>
+          <a:ln>
+            <a:noFill/>
+          </a:ln>
+          <a:effectLst/>
+        </p:spPr>
+        <p:style>
+          <a:lnRef idx="1">
+            <a:schemeClr val="accent1"/>
+          </a:lnRef>
+          <a:fillRef idx="3">
+            <a:schemeClr val="accent1"/>
+          </a:fillRef>
+          <a:effectRef idx="2">
+            <a:schemeClr val="accent1"/>
+          </a:effectRef>
+          <a:fontRef idx="minor">
+            <a:schemeClr val="lt1"/>
+          </a:fontRef>
+        </p:style>
+        <p:txBody>
+          <a:bodyPr rtlCol="0" anchor="ctr" wrap="square" lIns="0" rIns="0" tIns="0" bIns="0"/>
+          <a:lstStyle/>
+          <a:p>
+            <a:pPr algn="ctr"/>
+            <a:r>
+              <a:rPr sz="2600" b="1">
+                <a:solidFill>
+                  <a:srgbClr val="FFFFFF"/>
+                </a:solidFill>
+                <a:latin typeface="Calibri"/>
+              </a:rPr>
+              <a:t>2</a:t>
+            </a:r>
+          </a:p>
+        </p:txBody>
+      </p:sp>
+      <p:sp>
+        <p:nvSpPr>
+          <p:cNvPr id="11" name="TextBox 10"/>
+          <p:cNvSpPr txBox="1"/>
+          <p:nvPr/>
+        </p:nvSpPr>
+        <p:spPr>
+          <a:xfrm>
+            <a:off x="1645920" y="2651760"/>
+            <a:ext cx="3017520" cy="914400"/>
+          </a:xfrm>
+          <a:prstGeom prst="rect">
+            <a:avLst/>
+          </a:prstGeom>
+          <a:noFill/>
+        </p:spPr>
+        <p:txBody>
+          <a:bodyPr wrap="square" anchor="ctr" lIns="45720" rIns="45720">
+            <a:spAutoFit/>
+          </a:bodyPr>
+          <a:lstStyle/>
+          <a:p>
+            <a:pPr algn="l"/>
+            <a:r>
+              <a:rPr sz="2400" b="1">
+                <a:solidFill>
+                  <a:srgbClr val="1B263B"/>
+                </a:solidFill>
+                <a:latin typeface="Calibri"/>
+              </a:rPr>
+              <a:t>A discrepancy dataset</a:t>
+            </a:r>
+          </a:p>
+        </p:txBody>
+      </p:sp>
+      <p:sp>
+        <p:nvSpPr>
+          <p:cNvPr id="12" name="TextBox 11"/>
+          <p:cNvSpPr txBox="1"/>
+          <p:nvPr/>
+        </p:nvSpPr>
+        <p:spPr>
+          <a:xfrm>
+            <a:off x="4754880" y="2651760"/>
+            <a:ext cx="6796735" cy="914400"/>
+          </a:xfrm>
+          <a:prstGeom prst="rect">
+            <a:avLst/>
+          </a:prstGeom>
+          <a:noFill/>
+        </p:spPr>
+        <p:txBody>
+          <a:bodyPr wrap="square" anchor="ctr" lIns="45720" rIns="45720">
+            <a:spAutoFit/>
+          </a:bodyPr>
+          <a:lstStyle/>
+          <a:p>
+            <a:pPr algn="l"/>
+            <a:r>
+              <a:rPr sz="1800" b="0">
+                <a:solidFill>
+                  <a:srgbClr val="1B263B"/>
+                </a:solidFill>
+                <a:latin typeface="Calibri"/>
+              </a:rPr>
+              <a:t>Disagreements classified as real bug, intended, known or harness noise, with evidence, reusable by others.</a:t>
+            </a:r>
+          </a:p>
+        </p:txBody>
+      </p:sp>
+      <p:sp>
+        <p:nvSpPr>
+          <p:cNvPr id="13" name="Oval 12"/>
+          <p:cNvSpPr/>
+          <p:nvPr/>
+        </p:nvSpPr>
+        <p:spPr>
+          <a:xfrm>
+            <a:off x="685800" y="3977640"/>
+            <a:ext cx="640080" cy="640080"/>
+          </a:xfrm>
+          <a:prstGeom prst="ellipse">
+            <a:avLst/>
+          </a:prstGeom>
+          <a:solidFill>
+            <a:srgbClr val="1F6FB5"/>
+          </a:solidFill>
+          <a:ln>
+            <a:noFill/>
+          </a:ln>
+          <a:effectLst/>
+        </p:spPr>
+        <p:style>
+          <a:lnRef idx="1">
+            <a:schemeClr val="accent1"/>
+          </a:lnRef>
+          <a:fillRef idx="3">
+            <a:schemeClr val="accent1"/>
+          </a:fillRef>
+          <a:effectRef idx="2">
+            <a:schemeClr val="accent1"/>
+          </a:effectRef>
+          <a:fontRef idx="minor">
+            <a:schemeClr val="lt1"/>
+          </a:fontRef>
+        </p:style>
+        <p:txBody>
+          <a:bodyPr rtlCol="0" anchor="ctr" wrap="square" lIns="0" rIns="0" tIns="0" bIns="0"/>
+          <a:lstStyle/>
+          <a:p>
+            <a:pPr algn="ctr"/>
+            <a:r>
+              <a:rPr sz="2600" b="1">
+                <a:solidFill>
+                  <a:srgbClr val="FFFFFF"/>
+                </a:solidFill>
+                <a:latin typeface="Calibri"/>
+              </a:rPr>
+              <a:t>3</a:t>
+            </a:r>
+          </a:p>
+        </p:txBody>
+      </p:sp>
+      <p:sp>
+        <p:nvSpPr>
+          <p:cNvPr id="14" name="TextBox 13"/>
+          <p:cNvSpPr txBox="1"/>
+          <p:nvPr/>
+        </p:nvSpPr>
+        <p:spPr>
+          <a:xfrm>
+            <a:off x="1645920" y="3840480"/>
+            <a:ext cx="3017520" cy="914400"/>
+          </a:xfrm>
+          <a:prstGeom prst="rect">
+            <a:avLst/>
+          </a:prstGeom>
+          <a:noFill/>
+        </p:spPr>
+        <p:txBody>
+          <a:bodyPr wrap="square" anchor="ctr" lIns="45720" rIns="45720">
+            <a:spAutoFit/>
+          </a:bodyPr>
+          <a:lstStyle/>
+          <a:p>
+            <a:pPr algn="l"/>
+            <a:r>
+              <a:rPr sz="2400" b="1">
+                <a:solidFill>
+                  <a:srgbClr val="1B263B"/>
+                </a:solidFill>
+                <a:latin typeface="Calibri"/>
+              </a:rPr>
+              <a:t>A reusable pipeline</a:t>
+            </a:r>
+          </a:p>
+        </p:txBody>
+      </p:sp>
+      <p:sp>
+        <p:nvSpPr>
+          <p:cNvPr id="15" name="TextBox 14"/>
+          <p:cNvSpPr txBox="1"/>
+          <p:nvPr/>
+        </p:nvSpPr>
+        <p:spPr>
+          <a:xfrm>
+            <a:off x="4754880" y="3840480"/>
+            <a:ext cx="6796735" cy="914400"/>
+          </a:xfrm>
+          <a:prstGeom prst="rect">
+            <a:avLst/>
+          </a:prstGeom>
+          <a:noFill/>
+        </p:spPr>
+        <p:txBody>
+          <a:bodyPr wrap="square" anchor="ctr" lIns="45720" rIns="45720">
+            <a:spAutoFit/>
+          </a:bodyPr>
+          <a:lstStyle/>
+          <a:p>
+            <a:pPr algn="l"/>
+            <a:r>
+              <a:rPr sz="1800" b="0">
+                <a:solidFill>
+                  <a:srgbClr val="1B263B"/>
+                </a:solidFill>
+                <a:latin typeface="Calibri"/>
+              </a:rPr>
+              <a:t>Knowledge base and triage discard known differences cheaply, so humans review only real candidates. Funnel numbers: programs, disagreements, candidates, confirmed, filed.</a:t>
             </a:r>
           </a:p>
         </p:txBody>

</xml_diff>